<commit_message>
Add speaker notes, episode thumbnails, and HTML slide preview
- claude-code-onboarding.pptx: presenter notes on all 37 slides (timing + talking points)
- assets/thumb-ep1..8.png: YouTube thumbnails for the tutorial series
- preview.html: self-contained slide viewer with notes and keyboard navigation

Co-Authored-By: Claude Fable 5 <noreply@anthropic.com>
Claude-Session: https://claude.ai/code/session_01DSLyHeBC2AFTHW1Sivwwtv
</commit_message>
<xml_diff>
--- a/docs/onboarding/claude-code-onboarding.pptx
+++ b/docs/onboarding/claude-code-onboarding.pptx
@@ -141,6 +141,3091 @@
     </a:lvl9pPr>
   </p:defaultTextStyle>
 </p:presentation>
+</file>
+
+<file path=ppt/notesMasters/notesMaster1.xml><?xml version="1.0" encoding="utf-8"?>
+<p:notesMaster xmlns:a="http://schemas.openxmlformats.org/drawingml/2006/main" xmlns:p="http://schemas.openxmlformats.org/presentationml/2006/main" xmlns:r="http://schemas.openxmlformats.org/officeDocument/2006/relationships">
+  <p:cSld>
+    <p:bg>
+      <p:bgRef idx="1001">
+        <a:schemeClr val="bg1"/>
+      </p:bgRef>
+    </p:bg>
+    <p:spTree>
+      <p:nvGrpSpPr>
+        <p:cNvPr id="1" name=""/>
+        <p:cNvGrpSpPr/>
+        <p:nvPr/>
+      </p:nvGrpSpPr>
+      <p:grpSpPr>
+        <a:xfrm>
+          <a:off x="0" y="0"/>
+          <a:ext cx="0" cy="0"/>
+          <a:chOff x="0" y="0"/>
+          <a:chExt cx="0" cy="0"/>
+        </a:xfrm>
+      </p:grpSpPr>
+      <p:sp>
+        <p:nvSpPr>
+          <p:cNvPr id="2" name="Header Placeholder 1"/>
+          <p:cNvSpPr>
+            <a:spLocks noGrp="1"/>
+          </p:cNvSpPr>
+          <p:nvPr>
+            <p:ph type="hdr" sz="quarter"/>
+          </p:nvPr>
+        </p:nvSpPr>
+        <p:spPr>
+          <a:xfrm>
+            <a:off x="0" y="0"/>
+            <a:ext cx="2971800" cy="457200"/>
+          </a:xfrm>
+          <a:prstGeom prst="rect">
+            <a:avLst/>
+          </a:prstGeom>
+        </p:spPr>
+        <p:txBody>
+          <a:bodyPr vert="horz" lIns="91440" tIns="45720" rIns="91440" bIns="45720" rtlCol="0"/>
+          <a:lstStyle>
+            <a:lvl1pPr algn="l">
+              <a:defRPr sz="1200"/>
+            </a:lvl1pPr>
+          </a:lstStyle>
+          <a:p>
+            <a:endParaRPr lang="en-US"/>
+          </a:p>
+        </p:txBody>
+      </p:sp>
+      <p:sp>
+        <p:nvSpPr>
+          <p:cNvPr id="3" name="Date Placeholder 2"/>
+          <p:cNvSpPr>
+            <a:spLocks noGrp="1"/>
+          </p:cNvSpPr>
+          <p:nvPr>
+            <p:ph type="dt" idx="1"/>
+          </p:nvPr>
+        </p:nvSpPr>
+        <p:spPr>
+          <a:xfrm>
+            <a:off x="3884613" y="0"/>
+            <a:ext cx="2971800" cy="457200"/>
+          </a:xfrm>
+          <a:prstGeom prst="rect">
+            <a:avLst/>
+          </a:prstGeom>
+        </p:spPr>
+        <p:txBody>
+          <a:bodyPr vert="horz" lIns="91440" tIns="45720" rIns="91440" bIns="45720" rtlCol="0"/>
+          <a:lstStyle>
+            <a:lvl1pPr algn="r">
+              <a:defRPr sz="1200"/>
+            </a:lvl1pPr>
+          </a:lstStyle>
+          <a:p>
+            <a:fld id="{0F89C1C7-3DCD-1040-A9CF-14679D8B5DDD}" type="datetimeFigureOut">
+              <a:rPr lang="en-US" smtClean="0"/>
+              <a:t>10/17/16</a:t>
+            </a:fld>
+            <a:endParaRPr lang="en-US"/>
+          </a:p>
+        </p:txBody>
+      </p:sp>
+      <p:sp>
+        <p:nvSpPr>
+          <p:cNvPr id="4" name="Slide Image Placeholder 3"/>
+          <p:cNvSpPr>
+            <a:spLocks noGrp="1" noRot="1" noChangeAspect="1"/>
+          </p:cNvSpPr>
+          <p:nvPr>
+            <p:ph type="sldImg" idx="2"/>
+          </p:nvPr>
+        </p:nvSpPr>
+        <p:spPr>
+          <a:xfrm>
+            <a:off x="1143000" y="685800"/>
+            <a:ext cx="4572000" cy="3429000"/>
+          </a:xfrm>
+          <a:prstGeom prst="rect">
+            <a:avLst/>
+          </a:prstGeom>
+          <a:noFill/>
+          <a:ln w="12700">
+            <a:solidFill>
+              <a:prstClr val="black"/>
+            </a:solidFill>
+          </a:ln>
+        </p:spPr>
+        <p:txBody>
+          <a:bodyPr vert="horz" lIns="91440" tIns="45720" rIns="91440" bIns="45720" rtlCol="0" anchor="ctr"/>
+          <a:lstStyle/>
+          <a:p>
+            <a:endParaRPr lang="en-US"/>
+          </a:p>
+        </p:txBody>
+      </p:sp>
+      <p:sp>
+        <p:nvSpPr>
+          <p:cNvPr id="5" name="Notes Placeholder 4"/>
+          <p:cNvSpPr>
+            <a:spLocks noGrp="1"/>
+          </p:cNvSpPr>
+          <p:nvPr>
+            <p:ph type="body" sz="quarter" idx="3"/>
+          </p:nvPr>
+        </p:nvSpPr>
+        <p:spPr>
+          <a:xfrm>
+            <a:off x="685800" y="4343400"/>
+            <a:ext cx="5486400" cy="4114800"/>
+          </a:xfrm>
+          <a:prstGeom prst="rect">
+            <a:avLst/>
+          </a:prstGeom>
+        </p:spPr>
+        <p:txBody>
+          <a:bodyPr vert="horz" lIns="91440" tIns="45720" rIns="91440" bIns="45720" rtlCol="0"/>
+          <a:lstStyle/>
+          <a:p>
+            <a:pPr lvl="0"/>
+            <a:r>
+              <a:rPr lang="en-US" smtClean="0"/>
+              <a:t>Click to edit Master text styles</a:t>
+            </a:r>
+          </a:p>
+          <a:p>
+            <a:pPr lvl="1"/>
+            <a:r>
+              <a:rPr lang="en-US" smtClean="0"/>
+              <a:t>Second level</a:t>
+            </a:r>
+          </a:p>
+          <a:p>
+            <a:pPr lvl="2"/>
+            <a:r>
+              <a:rPr lang="en-US" smtClean="0"/>
+              <a:t>Third level</a:t>
+            </a:r>
+          </a:p>
+          <a:p>
+            <a:pPr lvl="3"/>
+            <a:r>
+              <a:rPr lang="en-US" smtClean="0"/>
+              <a:t>Fourth level</a:t>
+            </a:r>
+          </a:p>
+          <a:p>
+            <a:pPr lvl="4"/>
+            <a:r>
+              <a:rPr lang="en-US" smtClean="0"/>
+              <a:t>Fifth level</a:t>
+            </a:r>
+            <a:endParaRPr lang="en-US"/>
+          </a:p>
+        </p:txBody>
+      </p:sp>
+      <p:sp>
+        <p:nvSpPr>
+          <p:cNvPr id="6" name="Footer Placeholder 5"/>
+          <p:cNvSpPr>
+            <a:spLocks noGrp="1"/>
+          </p:cNvSpPr>
+          <p:nvPr>
+            <p:ph type="ftr" sz="quarter" idx="4"/>
+          </p:nvPr>
+        </p:nvSpPr>
+        <p:spPr>
+          <a:xfrm>
+            <a:off x="0" y="8685213"/>
+            <a:ext cx="2971800" cy="457200"/>
+          </a:xfrm>
+          <a:prstGeom prst="rect">
+            <a:avLst/>
+          </a:prstGeom>
+        </p:spPr>
+        <p:txBody>
+          <a:bodyPr vert="horz" lIns="91440" tIns="45720" rIns="91440" bIns="45720" rtlCol="0" anchor="b"/>
+          <a:lstStyle>
+            <a:lvl1pPr algn="l">
+              <a:defRPr sz="1200"/>
+            </a:lvl1pPr>
+          </a:lstStyle>
+          <a:p>
+            <a:endParaRPr lang="en-US"/>
+          </a:p>
+        </p:txBody>
+      </p:sp>
+      <p:sp>
+        <p:nvSpPr>
+          <p:cNvPr id="7" name="Slide Number Placeholder 6"/>
+          <p:cNvSpPr>
+            <a:spLocks noGrp="1"/>
+          </p:cNvSpPr>
+          <p:nvPr>
+            <p:ph type="sldNum" sz="quarter" idx="5"/>
+          </p:nvPr>
+        </p:nvSpPr>
+        <p:spPr>
+          <a:xfrm>
+            <a:off x="3884613" y="8685213"/>
+            <a:ext cx="2971800" cy="457200"/>
+          </a:xfrm>
+          <a:prstGeom prst="rect">
+            <a:avLst/>
+          </a:prstGeom>
+        </p:spPr>
+        <p:txBody>
+          <a:bodyPr vert="horz" lIns="91440" tIns="45720" rIns="91440" bIns="45720" rtlCol="0" anchor="b"/>
+          <a:lstStyle>
+            <a:lvl1pPr algn="r">
+              <a:defRPr sz="1200"/>
+            </a:lvl1pPr>
+          </a:lstStyle>
+          <a:p>
+            <a:fld id="{BB5E49A5-4136-284D-997B-48E1D791AD67}" type="slidenum">
+              <a:rPr lang="en-US" smtClean="0"/>
+              <a:t>‹#›</a:t>
+            </a:fld>
+            <a:endParaRPr lang="en-US"/>
+          </a:p>
+        </p:txBody>
+      </p:sp>
+    </p:spTree>
+    <p:extLst>
+      <p:ext uri="{BB962C8B-B14F-4D97-AF65-F5344CB8AC3E}">
+        <p14:creationId xmlns:p14="http://schemas.microsoft.com/office/powerpoint/2010/main" val="2623252185"/>
+      </p:ext>
+    </p:extLst>
+  </p:cSld>
+  <p:clrMap bg1="lt1" tx1="dk1" bg2="lt2" tx2="dk2" accent1="accent1" accent2="accent2" accent3="accent3" accent4="accent4" accent5="accent5" accent6="accent6" hlink="hlink" folHlink="folHlink"/>
+  <p:notesStyle>
+    <a:lvl1pPr marL="0" algn="l" defTabSz="457200" rtl="0" eaLnBrk="1" latinLnBrk="0" hangingPunct="1">
+      <a:defRPr sz="1200" kern="1200">
+        <a:solidFill>
+          <a:schemeClr val="tx1"/>
+        </a:solidFill>
+        <a:latin typeface="+mn-lt"/>
+        <a:ea typeface="+mn-ea"/>
+        <a:cs typeface="+mn-cs"/>
+      </a:defRPr>
+    </a:lvl1pPr>
+    <a:lvl2pPr marL="457200" algn="l" defTabSz="457200" rtl="0" eaLnBrk="1" latinLnBrk="0" hangingPunct="1">
+      <a:defRPr sz="1200" kern="1200">
+        <a:solidFill>
+          <a:schemeClr val="tx1"/>
+        </a:solidFill>
+        <a:latin typeface="+mn-lt"/>
+        <a:ea typeface="+mn-ea"/>
+        <a:cs typeface="+mn-cs"/>
+      </a:defRPr>
+    </a:lvl2pPr>
+    <a:lvl3pPr marL="914400" algn="l" defTabSz="457200" rtl="0" eaLnBrk="1" latinLnBrk="0" hangingPunct="1">
+      <a:defRPr sz="1200" kern="1200">
+        <a:solidFill>
+          <a:schemeClr val="tx1"/>
+        </a:solidFill>
+        <a:latin typeface="+mn-lt"/>
+        <a:ea typeface="+mn-ea"/>
+        <a:cs typeface="+mn-cs"/>
+      </a:defRPr>
+    </a:lvl3pPr>
+    <a:lvl4pPr marL="1371600" algn="l" defTabSz="457200" rtl="0" eaLnBrk="1" latinLnBrk="0" hangingPunct="1">
+      <a:defRPr sz="1200" kern="1200">
+        <a:solidFill>
+          <a:schemeClr val="tx1"/>
+        </a:solidFill>
+        <a:latin typeface="+mn-lt"/>
+        <a:ea typeface="+mn-ea"/>
+        <a:cs typeface="+mn-cs"/>
+      </a:defRPr>
+    </a:lvl4pPr>
+    <a:lvl5pPr marL="1828800" algn="l" defTabSz="457200" rtl="0" eaLnBrk="1" latinLnBrk="0" hangingPunct="1">
+      <a:defRPr sz="1200" kern="1200">
+        <a:solidFill>
+          <a:schemeClr val="tx1"/>
+        </a:solidFill>
+        <a:latin typeface="+mn-lt"/>
+        <a:ea typeface="+mn-ea"/>
+        <a:cs typeface="+mn-cs"/>
+      </a:defRPr>
+    </a:lvl5pPr>
+    <a:lvl6pPr marL="2286000" algn="l" defTabSz="457200" rtl="0" eaLnBrk="1" latinLnBrk="0" hangingPunct="1">
+      <a:defRPr sz="1200" kern="1200">
+        <a:solidFill>
+          <a:schemeClr val="tx1"/>
+        </a:solidFill>
+        <a:latin typeface="+mn-lt"/>
+        <a:ea typeface="+mn-ea"/>
+        <a:cs typeface="+mn-cs"/>
+      </a:defRPr>
+    </a:lvl6pPr>
+    <a:lvl7pPr marL="2743200" algn="l" defTabSz="457200" rtl="0" eaLnBrk="1" latinLnBrk="0" hangingPunct="1">
+      <a:defRPr sz="1200" kern="1200">
+        <a:solidFill>
+          <a:schemeClr val="tx1"/>
+        </a:solidFill>
+        <a:latin typeface="+mn-lt"/>
+        <a:ea typeface="+mn-ea"/>
+        <a:cs typeface="+mn-cs"/>
+      </a:defRPr>
+    </a:lvl7pPr>
+    <a:lvl8pPr marL="3200400" algn="l" defTabSz="457200" rtl="0" eaLnBrk="1" latinLnBrk="0" hangingPunct="1">
+      <a:defRPr sz="1200" kern="1200">
+        <a:solidFill>
+          <a:schemeClr val="tx1"/>
+        </a:solidFill>
+        <a:latin typeface="+mn-lt"/>
+        <a:ea typeface="+mn-ea"/>
+        <a:cs typeface="+mn-cs"/>
+      </a:defRPr>
+    </a:lvl8pPr>
+    <a:lvl9pPr marL="3657600" algn="l" defTabSz="457200" rtl="0" eaLnBrk="1" latinLnBrk="0" hangingPunct="1">
+      <a:defRPr sz="1200" kern="1200">
+        <a:solidFill>
+          <a:schemeClr val="tx1"/>
+        </a:solidFill>
+        <a:latin typeface="+mn-lt"/>
+        <a:ea typeface="+mn-ea"/>
+        <a:cs typeface="+mn-cs"/>
+      </a:defRPr>
+    </a:lvl9pPr>
+  </p:notesStyle>
+</p:notesMaster>
+</file>
+
+<file path=ppt/notesSlides/notesSlide1.xml><?xml version="1.0" encoding="utf-8"?>
+<p:notes xmlns:a="http://schemas.openxmlformats.org/drawingml/2006/main" xmlns:p="http://schemas.openxmlformats.org/presentationml/2006/main" xmlns:r="http://schemas.openxmlformats.org/officeDocument/2006/relationships">
+  <p:cSld>
+    <p:spTree>
+      <p:nvGrpSpPr>
+        <p:cNvPr id="1" name=""/>
+        <p:cNvGrpSpPr/>
+        <p:nvPr/>
+      </p:nvGrpSpPr>
+      <p:grpSpPr>
+        <a:xfrm>
+          <a:off x="0" y="0"/>
+          <a:ext cx="0" cy="0"/>
+          <a:chOff x="0" y="0"/>
+          <a:chExt cx="0" cy="0"/>
+        </a:xfrm>
+      </p:grpSpPr>
+      <p:sp>
+        <p:nvSpPr>
+          <p:cNvPr id="2" name="Slide Image Placeholder 1"/>
+          <p:cNvSpPr>
+            <a:spLocks noGrp="1"/>
+          </p:cNvSpPr>
+          <p:nvPr>
+            <p:ph type="sldImg" idx="2"/>
+          </p:nvPr>
+        </p:nvSpPr>
+        <p:spPr/>
+      </p:sp>
+      <p:sp>
+        <p:nvSpPr>
+          <p:cNvPr id="3" name="Notes Placeholder 2"/>
+          <p:cNvSpPr>
+            <a:spLocks noGrp="1"/>
+          </p:cNvSpPr>
+          <p:nvPr>
+            <p:ph type="body" idx="3" sz="quarter"/>
+          </p:nvPr>
+        </p:nvSpPr>
+        <p:spPr/>
+        <p:txBody>
+          <a:bodyPr/>
+          <a:lstStyle/>
+          <a:p>
+            <a:r>
+              <a:t>(1분) 인사 후: "혹시 AI 코딩 도구, 자동완성까지만 써보신 분?" 손들게 하며 시작.</a:t>
+            </a:r>
+          </a:p>
+          <a:p>
+            <a:r>
+              <a:t>오늘 목표는 단 하나 — 끝나고 자리로 돌아가서 바로 claude를 켜게 만드는 것.</a:t>
+            </a:r>
+          </a:p>
+        </p:txBody>
+      </p:sp>
+      <p:sp>
+        <p:nvSpPr>
+          <p:cNvPr id="4" name="Slide Number Placeholder 3"/>
+          <p:cNvSpPr>
+            <a:spLocks noGrp="1"/>
+          </p:cNvSpPr>
+          <p:nvPr>
+            <p:ph type="sldNum" idx="5" sz="quarter"/>
+          </p:nvPr>
+        </p:nvSpPr>
+        <p:spPr/>
+      </p:sp>
+    </p:spTree>
+  </p:cSld>
+  <p:clrMapOvr>
+    <a:masterClrMapping/>
+  </p:clrMapOvr>
+</p:notes>
+</file>
+
+<file path=ppt/notesSlides/notesSlide10.xml><?xml version="1.0" encoding="utf-8"?>
+<p:notes xmlns:a="http://schemas.openxmlformats.org/drawingml/2006/main" xmlns:p="http://schemas.openxmlformats.org/presentationml/2006/main" xmlns:r="http://schemas.openxmlformats.org/officeDocument/2006/relationships">
+  <p:cSld>
+    <p:spTree>
+      <p:nvGrpSpPr>
+        <p:cNvPr id="1" name=""/>
+        <p:cNvGrpSpPr/>
+        <p:nvPr/>
+      </p:nvGrpSpPr>
+      <p:grpSpPr>
+        <a:xfrm>
+          <a:off x="0" y="0"/>
+          <a:ext cx="0" cy="0"/>
+          <a:chOff x="0" y="0"/>
+          <a:chExt cx="0" cy="0"/>
+        </a:xfrm>
+      </p:grpSpPr>
+      <p:sp>
+        <p:nvSpPr>
+          <p:cNvPr id="2" name="Slide Image Placeholder 1"/>
+          <p:cNvSpPr>
+            <a:spLocks noGrp="1"/>
+          </p:cNvSpPr>
+          <p:nvPr>
+            <p:ph type="sldImg" idx="2"/>
+          </p:nvPr>
+        </p:nvSpPr>
+        <p:spPr/>
+      </p:sp>
+      <p:sp>
+        <p:nvSpPr>
+          <p:cNvPr id="3" name="Notes Placeholder 2"/>
+          <p:cNvSpPr>
+            <a:spLocks noGrp="1"/>
+          </p:cNvSpPr>
+          <p:nvPr>
+            <p:ph type="body" idx="3" sz="quarter"/>
+          </p:nvPr>
+        </p:nvSpPr>
+        <p:spPr/>
+        <p:txBody>
+          <a:bodyPr/>
+          <a:lstStyle/>
+          <a:p>
+            <a:r>
+              <a:t>(30초) "여기서부터 30분 코스입니다. 오늘 이것만 가져가셔도 성공."</a:t>
+            </a:r>
+          </a:p>
+        </p:txBody>
+      </p:sp>
+      <p:sp>
+        <p:nvSpPr>
+          <p:cNvPr id="4" name="Slide Number Placeholder 3"/>
+          <p:cNvSpPr>
+            <a:spLocks noGrp="1"/>
+          </p:cNvSpPr>
+          <p:nvPr>
+            <p:ph type="sldNum" idx="5" sz="quarter"/>
+          </p:nvPr>
+        </p:nvSpPr>
+        <p:spPr/>
+      </p:sp>
+    </p:spTree>
+  </p:cSld>
+  <p:clrMapOvr>
+    <a:masterClrMapping/>
+  </p:clrMapOvr>
+</p:notes>
+</file>
+
+<file path=ppt/notesSlides/notesSlide11.xml><?xml version="1.0" encoding="utf-8"?>
+<p:notes xmlns:a="http://schemas.openxmlformats.org/drawingml/2006/main" xmlns:p="http://schemas.openxmlformats.org/presentationml/2006/main" xmlns:r="http://schemas.openxmlformats.org/officeDocument/2006/relationships">
+  <p:cSld>
+    <p:spTree>
+      <p:nvGrpSpPr>
+        <p:cNvPr id="1" name=""/>
+        <p:cNvGrpSpPr/>
+        <p:nvPr/>
+      </p:nvGrpSpPr>
+      <p:grpSpPr>
+        <a:xfrm>
+          <a:off x="0" y="0"/>
+          <a:ext cx="0" cy="0"/>
+          <a:chOff x="0" y="0"/>
+          <a:chExt cx="0" cy="0"/>
+        </a:xfrm>
+      </p:grpSpPr>
+      <p:sp>
+        <p:nvSpPr>
+          <p:cNvPr id="2" name="Slide Image Placeholder 1"/>
+          <p:cNvSpPr>
+            <a:spLocks noGrp="1"/>
+          </p:cNvSpPr>
+          <p:nvPr>
+            <p:ph type="sldImg" idx="2"/>
+          </p:nvPr>
+        </p:nvSpPr>
+        <p:spPr/>
+      </p:sp>
+      <p:sp>
+        <p:nvSpPr>
+          <p:cNvPr id="3" name="Notes Placeholder 2"/>
+          <p:cNvSpPr>
+            <a:spLocks noGrp="1"/>
+          </p:cNvSpPr>
+          <p:nvPr>
+            <p:ph type="body" idx="3" sz="quarter"/>
+          </p:nvPr>
+        </p:nvSpPr>
+        <p:spPr/>
+        <p:txBody>
+          <a:bodyPr/>
+          <a:lstStyle/>
+          <a:p>
+            <a:r>
+              <a:t>(2분) 신규 입사자 온보딩 사례로 공감 유도 — "코드 파악 2주 → 이틀".</a:t>
+            </a:r>
+          </a:p>
+          <a:p>
+            <a:r>
+              <a:t>활용 예 3개 중 청중 업무에 가장 가까운 것을 골라 부연.</a:t>
+            </a:r>
+          </a:p>
+        </p:txBody>
+      </p:sp>
+      <p:sp>
+        <p:nvSpPr>
+          <p:cNvPr id="4" name="Slide Number Placeholder 3"/>
+          <p:cNvSpPr>
+            <a:spLocks noGrp="1"/>
+          </p:cNvSpPr>
+          <p:nvPr>
+            <p:ph type="sldNum" idx="5" sz="quarter"/>
+          </p:nvPr>
+        </p:nvSpPr>
+        <p:spPr/>
+      </p:sp>
+    </p:spTree>
+  </p:cSld>
+  <p:clrMapOvr>
+    <a:masterClrMapping/>
+  </p:clrMapOvr>
+</p:notes>
+</file>
+
+<file path=ppt/notesSlides/notesSlide12.xml><?xml version="1.0" encoding="utf-8"?>
+<p:notes xmlns:a="http://schemas.openxmlformats.org/drawingml/2006/main" xmlns:p="http://schemas.openxmlformats.org/presentationml/2006/main" xmlns:r="http://schemas.openxmlformats.org/officeDocument/2006/relationships">
+  <p:cSld>
+    <p:spTree>
+      <p:nvGrpSpPr>
+        <p:cNvPr id="1" name=""/>
+        <p:cNvGrpSpPr/>
+        <p:nvPr/>
+      </p:nvGrpSpPr>
+      <p:grpSpPr>
+        <a:xfrm>
+          <a:off x="0" y="0"/>
+          <a:ext cx="0" cy="0"/>
+          <a:chOff x="0" y="0"/>
+          <a:chExt cx="0" cy="0"/>
+        </a:xfrm>
+      </p:grpSpPr>
+      <p:sp>
+        <p:nvSpPr>
+          <p:cNvPr id="2" name="Slide Image Placeholder 1"/>
+          <p:cNvSpPr>
+            <a:spLocks noGrp="1"/>
+          </p:cNvSpPr>
+          <p:nvPr>
+            <p:ph type="sldImg" idx="2"/>
+          </p:nvPr>
+        </p:nvSpPr>
+        <p:spPr/>
+      </p:sp>
+      <p:sp>
+        <p:nvSpPr>
+          <p:cNvPr id="3" name="Notes Placeholder 2"/>
+          <p:cNvSpPr>
+            <a:spLocks noGrp="1"/>
+          </p:cNvSpPr>
+          <p:nvPr>
+            <p:ph type="body" idx="3" sz="quarter"/>
+          </p:nvPr>
+        </p:nvSpPr>
+        <p:spPr/>
+        <p:txBody>
+          <a:bodyPr/>
+          <a:lstStyle/>
+          <a:p>
+            <a:r>
+              <a:t>(2분) 좌우 대비가 핵심 슬라이드. 왼쪽 요청도 '되긴 되지만' 왕복이 늘어난다고 설명.</a:t>
+            </a:r>
+          </a:p>
+          <a:p>
+            <a:r>
+              <a:t>TIP 공식(대상·동작·제약)을 소리 내어 읽고 예시 하나 즉석에서 만들어 보이기.</a:t>
+            </a:r>
+          </a:p>
+        </p:txBody>
+      </p:sp>
+      <p:sp>
+        <p:nvSpPr>
+          <p:cNvPr id="4" name="Slide Number Placeholder 3"/>
+          <p:cNvSpPr>
+            <a:spLocks noGrp="1"/>
+          </p:cNvSpPr>
+          <p:nvPr>
+            <p:ph type="sldNum" idx="5" sz="quarter"/>
+          </p:nvPr>
+        </p:nvSpPr>
+        <p:spPr/>
+      </p:sp>
+    </p:spTree>
+  </p:cSld>
+  <p:clrMapOvr>
+    <a:masterClrMapping/>
+  </p:clrMapOvr>
+</p:notes>
+</file>
+
+<file path=ppt/notesSlides/notesSlide13.xml><?xml version="1.0" encoding="utf-8"?>
+<p:notes xmlns:a="http://schemas.openxmlformats.org/drawingml/2006/main" xmlns:p="http://schemas.openxmlformats.org/presentationml/2006/main" xmlns:r="http://schemas.openxmlformats.org/officeDocument/2006/relationships">
+  <p:cSld>
+    <p:spTree>
+      <p:nvGrpSpPr>
+        <p:cNvPr id="1" name=""/>
+        <p:cNvGrpSpPr/>
+        <p:nvPr/>
+      </p:nvGrpSpPr>
+      <p:grpSpPr>
+        <a:xfrm>
+          <a:off x="0" y="0"/>
+          <a:ext cx="0" cy="0"/>
+          <a:chOff x="0" y="0"/>
+          <a:chExt cx="0" cy="0"/>
+        </a:xfrm>
+      </p:grpSpPr>
+      <p:sp>
+        <p:nvSpPr>
+          <p:cNvPr id="2" name="Slide Image Placeholder 1"/>
+          <p:cNvSpPr>
+            <a:spLocks noGrp="1"/>
+          </p:cNvSpPr>
+          <p:nvPr>
+            <p:ph type="sldImg" idx="2"/>
+          </p:nvPr>
+        </p:nvSpPr>
+        <p:spPr/>
+      </p:sp>
+      <p:sp>
+        <p:nvSpPr>
+          <p:cNvPr id="3" name="Notes Placeholder 2"/>
+          <p:cNvSpPr>
+            <a:spLocks noGrp="1"/>
+          </p:cNvSpPr>
+          <p:nvPr>
+            <p:ph type="body" idx="3" sz="quarter"/>
+          </p:nvPr>
+        </p:nvSpPr>
+        <p:spPr/>
+        <p:txBody>
+          <a:bodyPr/>
+          <a:lstStyle/>
+          <a:p>
+            <a:r>
+              <a:t>(1분) 다 외울 필요 없음 — "/ 만 치면 목록이 뜹니다."</a:t>
+            </a:r>
+          </a:p>
+          <a:p>
+            <a:r>
+              <a:t>/init은 Level 2 예고편으로만 언급하고 넘어가기.</a:t>
+            </a:r>
+          </a:p>
+        </p:txBody>
+      </p:sp>
+      <p:sp>
+        <p:nvSpPr>
+          <p:cNvPr id="4" name="Slide Number Placeholder 3"/>
+          <p:cNvSpPr>
+            <a:spLocks noGrp="1"/>
+          </p:cNvSpPr>
+          <p:nvPr>
+            <p:ph type="sldNum" idx="5" sz="quarter"/>
+          </p:nvPr>
+        </p:nvSpPr>
+        <p:spPr/>
+      </p:sp>
+    </p:spTree>
+  </p:cSld>
+  <p:clrMapOvr>
+    <a:masterClrMapping/>
+  </p:clrMapOvr>
+</p:notes>
+</file>
+
+<file path=ppt/notesSlides/notesSlide14.xml><?xml version="1.0" encoding="utf-8"?>
+<p:notes xmlns:a="http://schemas.openxmlformats.org/drawingml/2006/main" xmlns:p="http://schemas.openxmlformats.org/presentationml/2006/main" xmlns:r="http://schemas.openxmlformats.org/officeDocument/2006/relationships">
+  <p:cSld>
+    <p:spTree>
+      <p:nvGrpSpPr>
+        <p:cNvPr id="1" name=""/>
+        <p:cNvGrpSpPr/>
+        <p:nvPr/>
+      </p:nvGrpSpPr>
+      <p:grpSpPr>
+        <a:xfrm>
+          <a:off x="0" y="0"/>
+          <a:ext cx="0" cy="0"/>
+          <a:chOff x="0" y="0"/>
+          <a:chExt cx="0" cy="0"/>
+        </a:xfrm>
+      </p:grpSpPr>
+      <p:sp>
+        <p:nvSpPr>
+          <p:cNvPr id="2" name="Slide Image Placeholder 1"/>
+          <p:cNvSpPr>
+            <a:spLocks noGrp="1"/>
+          </p:cNvSpPr>
+          <p:nvPr>
+            <p:ph type="sldImg" idx="2"/>
+          </p:nvPr>
+        </p:nvSpPr>
+        <p:spPr/>
+      </p:sp>
+      <p:sp>
+        <p:nvSpPr>
+          <p:cNvPr id="3" name="Notes Placeholder 2"/>
+          <p:cNvSpPr>
+            <a:spLocks noGrp="1"/>
+          </p:cNvSpPr>
+          <p:nvPr>
+            <p:ph type="body" idx="3" sz="quarter"/>
+          </p:nvPr>
+        </p:nvSpPr>
+        <p:spPr/>
+        <p:txBody>
+          <a:bodyPr/>
+          <a:lstStyle/>
+          <a:p>
+            <a:r>
+              <a:t>(2분) Esc Esc(되돌리기)가 오늘 발표에서 가장 박수 받는 기능 — 시연 가치 높음.</a:t>
+            </a:r>
+          </a:p>
+          <a:p>
+            <a:r>
+              <a:t>claude -c는 "터미널 껐다고 대화가 사라지지 않는다"는 안심 포인트.</a:t>
+            </a:r>
+          </a:p>
+        </p:txBody>
+      </p:sp>
+      <p:sp>
+        <p:nvSpPr>
+          <p:cNvPr id="4" name="Slide Number Placeholder 3"/>
+          <p:cNvSpPr>
+            <a:spLocks noGrp="1"/>
+          </p:cNvSpPr>
+          <p:nvPr>
+            <p:ph type="sldNum" idx="5" sz="quarter"/>
+          </p:nvPr>
+        </p:nvSpPr>
+        <p:spPr/>
+      </p:sp>
+    </p:spTree>
+  </p:cSld>
+  <p:clrMapOvr>
+    <a:masterClrMapping/>
+  </p:clrMapOvr>
+</p:notes>
+</file>
+
+<file path=ppt/notesSlides/notesSlide15.xml><?xml version="1.0" encoding="utf-8"?>
+<p:notes xmlns:a="http://schemas.openxmlformats.org/drawingml/2006/main" xmlns:p="http://schemas.openxmlformats.org/presentationml/2006/main" xmlns:r="http://schemas.openxmlformats.org/officeDocument/2006/relationships">
+  <p:cSld>
+    <p:spTree>
+      <p:nvGrpSpPr>
+        <p:cNvPr id="1" name=""/>
+        <p:cNvGrpSpPr/>
+        <p:nvPr/>
+      </p:nvGrpSpPr>
+      <p:grpSpPr>
+        <a:xfrm>
+          <a:off x="0" y="0"/>
+          <a:ext cx="0" cy="0"/>
+          <a:chOff x="0" y="0"/>
+          <a:chExt cx="0" cy="0"/>
+        </a:xfrm>
+      </p:grpSpPr>
+      <p:sp>
+        <p:nvSpPr>
+          <p:cNvPr id="2" name="Slide Image Placeholder 1"/>
+          <p:cNvSpPr>
+            <a:spLocks noGrp="1"/>
+          </p:cNvSpPr>
+          <p:nvPr>
+            <p:ph type="sldImg" idx="2"/>
+          </p:nvPr>
+        </p:nvSpPr>
+        <p:spPr/>
+      </p:sp>
+      <p:sp>
+        <p:nvSpPr>
+          <p:cNvPr id="3" name="Notes Placeholder 2"/>
+          <p:cNvSpPr>
+            <a:spLocks noGrp="1"/>
+          </p:cNvSpPr>
+          <p:nvPr>
+            <p:ph type="body" idx="3" sz="quarter"/>
+          </p:nvPr>
+        </p:nvSpPr>
+        <p:spPr/>
+        <p:txBody>
+          <a:bodyPr/>
+          <a:lstStyle/>
+          <a:p>
+            <a:r>
+              <a:t>(5분) 라이브 데모. 실패 대비 백업 GIF 준비 필수.</a:t>
+            </a:r>
+          </a:p>
+          <a:p>
+            <a:r>
+              <a:t>시나리오: 구조 질문 → 결과 표시 기능 추가 → 브라우저 확인. 승인 프롬프트에서 잠깐 멈추고 diff를 청중과 같이 읽기.</a:t>
+            </a:r>
+          </a:p>
+        </p:txBody>
+      </p:sp>
+      <p:sp>
+        <p:nvSpPr>
+          <p:cNvPr id="4" name="Slide Number Placeholder 3"/>
+          <p:cNvSpPr>
+            <a:spLocks noGrp="1"/>
+          </p:cNvSpPr>
+          <p:nvPr>
+            <p:ph type="sldNum" idx="5" sz="quarter"/>
+          </p:nvPr>
+        </p:nvSpPr>
+        <p:spPr/>
+      </p:sp>
+    </p:spTree>
+  </p:cSld>
+  <p:clrMapOvr>
+    <a:masterClrMapping/>
+  </p:clrMapOvr>
+</p:notes>
+</file>
+
+<file path=ppt/notesSlides/notesSlide16.xml><?xml version="1.0" encoding="utf-8"?>
+<p:notes xmlns:a="http://schemas.openxmlformats.org/drawingml/2006/main" xmlns:p="http://schemas.openxmlformats.org/presentationml/2006/main" xmlns:r="http://schemas.openxmlformats.org/officeDocument/2006/relationships">
+  <p:cSld>
+    <p:spTree>
+      <p:nvGrpSpPr>
+        <p:cNvPr id="1" name=""/>
+        <p:cNvGrpSpPr/>
+        <p:nvPr/>
+      </p:nvGrpSpPr>
+      <p:grpSpPr>
+        <a:xfrm>
+          <a:off x="0" y="0"/>
+          <a:ext cx="0" cy="0"/>
+          <a:chOff x="0" y="0"/>
+          <a:chExt cx="0" cy="0"/>
+        </a:xfrm>
+      </p:grpSpPr>
+      <p:sp>
+        <p:nvSpPr>
+          <p:cNvPr id="2" name="Slide Image Placeholder 1"/>
+          <p:cNvSpPr>
+            <a:spLocks noGrp="1"/>
+          </p:cNvSpPr>
+          <p:nvPr>
+            <p:ph type="sldImg" idx="2"/>
+          </p:nvPr>
+        </p:nvSpPr>
+        <p:spPr/>
+      </p:sp>
+      <p:sp>
+        <p:nvSpPr>
+          <p:cNvPr id="3" name="Notes Placeholder 2"/>
+          <p:cNvSpPr>
+            <a:spLocks noGrp="1"/>
+          </p:cNvSpPr>
+          <p:nvPr>
+            <p:ph type="body" idx="3" sz="quarter"/>
+          </p:nvPr>
+        </p:nvSpPr>
+        <p:spPr/>
+        <p:txBody>
+          <a:bodyPr/>
+          <a:lstStyle/>
+          <a:p>
+            <a:r>
+              <a:t>(1분) 실습 과제를 소리 내어 읽고 "오늘 퇴근 전에 딱 15분"이라고 구체적 시간 제시.</a:t>
+            </a:r>
+          </a:p>
+          <a:p>
+            <a:r>
+              <a:t>여기서 1차 질문 받기 (2~3개만).</a:t>
+            </a:r>
+          </a:p>
+        </p:txBody>
+      </p:sp>
+      <p:sp>
+        <p:nvSpPr>
+          <p:cNvPr id="4" name="Slide Number Placeholder 3"/>
+          <p:cNvSpPr>
+            <a:spLocks noGrp="1"/>
+          </p:cNvSpPr>
+          <p:nvPr>
+            <p:ph type="sldNum" idx="5" sz="quarter"/>
+          </p:nvPr>
+        </p:nvSpPr>
+        <p:spPr/>
+      </p:sp>
+    </p:spTree>
+  </p:cSld>
+  <p:clrMapOvr>
+    <a:masterClrMapping/>
+  </p:clrMapOvr>
+</p:notes>
+</file>
+
+<file path=ppt/notesSlides/notesSlide17.xml><?xml version="1.0" encoding="utf-8"?>
+<p:notes xmlns:a="http://schemas.openxmlformats.org/drawingml/2006/main" xmlns:p="http://schemas.openxmlformats.org/presentationml/2006/main" xmlns:r="http://schemas.openxmlformats.org/officeDocument/2006/relationships">
+  <p:cSld>
+    <p:spTree>
+      <p:nvGrpSpPr>
+        <p:cNvPr id="1" name=""/>
+        <p:cNvGrpSpPr/>
+        <p:nvPr/>
+      </p:nvGrpSpPr>
+      <p:grpSpPr>
+        <a:xfrm>
+          <a:off x="0" y="0"/>
+          <a:ext cx="0" cy="0"/>
+          <a:chOff x="0" y="0"/>
+          <a:chExt cx="0" cy="0"/>
+        </a:xfrm>
+      </p:grpSpPr>
+      <p:sp>
+        <p:nvSpPr>
+          <p:cNvPr id="2" name="Slide Image Placeholder 1"/>
+          <p:cNvSpPr>
+            <a:spLocks noGrp="1"/>
+          </p:cNvSpPr>
+          <p:nvPr>
+            <p:ph type="sldImg" idx="2"/>
+          </p:nvPr>
+        </p:nvSpPr>
+        <p:spPr/>
+      </p:sp>
+      <p:sp>
+        <p:nvSpPr>
+          <p:cNvPr id="3" name="Notes Placeholder 2"/>
+          <p:cNvSpPr>
+            <a:spLocks noGrp="1"/>
+          </p:cNvSpPr>
+          <p:nvPr>
+            <p:ph type="body" idx="3" sz="quarter"/>
+          </p:nvPr>
+        </p:nvSpPr>
+        <p:spPr/>
+        <p:txBody>
+          <a:bodyPr/>
+          <a:lstStyle/>
+          <a:p>
+            <a:r>
+              <a:t>(30초) "여기서부터는 '장난감'이 '업무 도구'가 되는 구간입니다."</a:t>
+            </a:r>
+          </a:p>
+        </p:txBody>
+      </p:sp>
+      <p:sp>
+        <p:nvSpPr>
+          <p:cNvPr id="4" name="Slide Number Placeholder 3"/>
+          <p:cNvSpPr>
+            <a:spLocks noGrp="1"/>
+          </p:cNvSpPr>
+          <p:nvPr>
+            <p:ph type="sldNum" idx="5" sz="quarter"/>
+          </p:nvPr>
+        </p:nvSpPr>
+        <p:spPr/>
+      </p:sp>
+    </p:spTree>
+  </p:cSld>
+  <p:clrMapOvr>
+    <a:masterClrMapping/>
+  </p:clrMapOvr>
+</p:notes>
+</file>
+
+<file path=ppt/notesSlides/notesSlide18.xml><?xml version="1.0" encoding="utf-8"?>
+<p:notes xmlns:a="http://schemas.openxmlformats.org/drawingml/2006/main" xmlns:p="http://schemas.openxmlformats.org/presentationml/2006/main" xmlns:r="http://schemas.openxmlformats.org/officeDocument/2006/relationships">
+  <p:cSld>
+    <p:spTree>
+      <p:nvGrpSpPr>
+        <p:cNvPr id="1" name=""/>
+        <p:cNvGrpSpPr/>
+        <p:nvPr/>
+      </p:nvGrpSpPr>
+      <p:grpSpPr>
+        <a:xfrm>
+          <a:off x="0" y="0"/>
+          <a:ext cx="0" cy="0"/>
+          <a:chOff x="0" y="0"/>
+          <a:chExt cx="0" cy="0"/>
+        </a:xfrm>
+      </p:grpSpPr>
+      <p:sp>
+        <p:nvSpPr>
+          <p:cNvPr id="2" name="Slide Image Placeholder 1"/>
+          <p:cNvSpPr>
+            <a:spLocks noGrp="1"/>
+          </p:cNvSpPr>
+          <p:nvPr>
+            <p:ph type="sldImg" idx="2"/>
+          </p:nvPr>
+        </p:nvSpPr>
+        <p:spPr/>
+      </p:sp>
+      <p:sp>
+        <p:nvSpPr>
+          <p:cNvPr id="3" name="Notes Placeholder 2"/>
+          <p:cNvSpPr>
+            <a:spLocks noGrp="1"/>
+          </p:cNvSpPr>
+          <p:nvPr>
+            <p:ph type="body" idx="3" sz="quarter"/>
+          </p:nvPr>
+        </p:nvSpPr>
+        <p:spPr/>
+        <p:txBody>
+          <a:bodyPr/>
+          <a:lstStyle/>
+          <a:p>
+            <a:r>
+              <a:t>(3분) 오늘 발표에서 가장 실용적인 슬라이드.</a:t>
+            </a:r>
+          </a:p>
+          <a:p>
+            <a:r>
+              <a:t>"매번 같은 설명을 반복하고 있다면 그게 CLAUDE.md에 들어갈 내용" — 팀 프로젝트라면 커밋해서 공유하라고 강조.</a:t>
+            </a:r>
+          </a:p>
+        </p:txBody>
+      </p:sp>
+      <p:sp>
+        <p:nvSpPr>
+          <p:cNvPr id="4" name="Slide Number Placeholder 3"/>
+          <p:cNvSpPr>
+            <a:spLocks noGrp="1"/>
+          </p:cNvSpPr>
+          <p:nvPr>
+            <p:ph type="sldNum" idx="5" sz="quarter"/>
+          </p:nvPr>
+        </p:nvSpPr>
+        <p:spPr/>
+      </p:sp>
+    </p:spTree>
+  </p:cSld>
+  <p:clrMapOvr>
+    <a:masterClrMapping/>
+  </p:clrMapOvr>
+</p:notes>
+</file>
+
+<file path=ppt/notesSlides/notesSlide19.xml><?xml version="1.0" encoding="utf-8"?>
+<p:notes xmlns:a="http://schemas.openxmlformats.org/drawingml/2006/main" xmlns:p="http://schemas.openxmlformats.org/presentationml/2006/main" xmlns:r="http://schemas.openxmlformats.org/officeDocument/2006/relationships">
+  <p:cSld>
+    <p:spTree>
+      <p:nvGrpSpPr>
+        <p:cNvPr id="1" name=""/>
+        <p:cNvGrpSpPr/>
+        <p:nvPr/>
+      </p:nvGrpSpPr>
+      <p:grpSpPr>
+        <a:xfrm>
+          <a:off x="0" y="0"/>
+          <a:ext cx="0" cy="0"/>
+          <a:chOff x="0" y="0"/>
+          <a:chExt cx="0" cy="0"/>
+        </a:xfrm>
+      </p:grpSpPr>
+      <p:sp>
+        <p:nvSpPr>
+          <p:cNvPr id="2" name="Slide Image Placeholder 1"/>
+          <p:cNvSpPr>
+            <a:spLocks noGrp="1"/>
+          </p:cNvSpPr>
+          <p:nvPr>
+            <p:ph type="sldImg" idx="2"/>
+          </p:nvPr>
+        </p:nvSpPr>
+        <p:spPr/>
+      </p:sp>
+      <p:sp>
+        <p:nvSpPr>
+          <p:cNvPr id="3" name="Notes Placeholder 2"/>
+          <p:cNvSpPr>
+            <a:spLocks noGrp="1"/>
+          </p:cNvSpPr>
+          <p:nvPr>
+            <p:ph type="body" idx="3" sz="quarter"/>
+          </p:nvPr>
+        </p:nvSpPr>
+        <p:spPr/>
+        <p:txBody>
+          <a:bodyPr/>
+          <a:lstStyle/>
+          <a:p>
+            <a:r>
+              <a:t>(2분) "큰 작업은 Plan Mode가 기본값"이라는 습관을 심는 게 목표.</a:t>
+            </a:r>
+          </a:p>
+          <a:p>
+            <a:r>
+              <a:t>계획 단계에서는 코드가 안 바뀌므로 부담 없이 퇴짜 놓아도 된다는 점 강조.</a:t>
+            </a:r>
+          </a:p>
+        </p:txBody>
+      </p:sp>
+      <p:sp>
+        <p:nvSpPr>
+          <p:cNvPr id="4" name="Slide Number Placeholder 3"/>
+          <p:cNvSpPr>
+            <a:spLocks noGrp="1"/>
+          </p:cNvSpPr>
+          <p:nvPr>
+            <p:ph type="sldNum" idx="5" sz="quarter"/>
+          </p:nvPr>
+        </p:nvSpPr>
+        <p:spPr/>
+      </p:sp>
+    </p:spTree>
+  </p:cSld>
+  <p:clrMapOvr>
+    <a:masterClrMapping/>
+  </p:clrMapOvr>
+</p:notes>
+</file>
+
+<file path=ppt/notesSlides/notesSlide2.xml><?xml version="1.0" encoding="utf-8"?>
+<p:notes xmlns:a="http://schemas.openxmlformats.org/drawingml/2006/main" xmlns:p="http://schemas.openxmlformats.org/presentationml/2006/main" xmlns:r="http://schemas.openxmlformats.org/officeDocument/2006/relationships">
+  <p:cSld>
+    <p:spTree>
+      <p:nvGrpSpPr>
+        <p:cNvPr id="1" name=""/>
+        <p:cNvGrpSpPr/>
+        <p:nvPr/>
+      </p:nvGrpSpPr>
+      <p:grpSpPr>
+        <a:xfrm>
+          <a:off x="0" y="0"/>
+          <a:ext cx="0" cy="0"/>
+          <a:chOff x="0" y="0"/>
+          <a:chExt cx="0" cy="0"/>
+        </a:xfrm>
+      </p:grpSpPr>
+      <p:sp>
+        <p:nvSpPr>
+          <p:cNvPr id="2" name="Slide Image Placeholder 1"/>
+          <p:cNvSpPr>
+            <a:spLocks noGrp="1"/>
+          </p:cNvSpPr>
+          <p:nvPr>
+            <p:ph type="sldImg" idx="2"/>
+          </p:nvPr>
+        </p:nvSpPr>
+        <p:spPr/>
+      </p:sp>
+      <p:sp>
+        <p:nvSpPr>
+          <p:cNvPr id="3" name="Notes Placeholder 2"/>
+          <p:cNvSpPr>
+            <a:spLocks noGrp="1"/>
+          </p:cNvSpPr>
+          <p:nvPr>
+            <p:ph type="body" idx="3" sz="quarter"/>
+          </p:nvPr>
+        </p:nvSpPr>
+        <p:spPr/>
+        <p:txBody>
+          <a:bodyPr/>
+          <a:lstStyle/>
+          <a:p>
+            <a:r>
+              <a:t>(1분) 기능이 많아 보여도 오늘 다 외울 필요 없다고 안심시키기.</a:t>
+            </a:r>
+          </a:p>
+          <a:p>
+            <a:r>
+              <a:t>"Level 1만 따라 하면 오늘부터 씁니다. 2·3은 필요할 때 이 자료로 돌아오세요." — 심리적 부담 낮추는 게 목적.</a:t>
+            </a:r>
+          </a:p>
+        </p:txBody>
+      </p:sp>
+      <p:sp>
+        <p:nvSpPr>
+          <p:cNvPr id="4" name="Slide Number Placeholder 3"/>
+          <p:cNvSpPr>
+            <a:spLocks noGrp="1"/>
+          </p:cNvSpPr>
+          <p:nvPr>
+            <p:ph type="sldNum" idx="5" sz="quarter"/>
+          </p:nvPr>
+        </p:nvSpPr>
+        <p:spPr/>
+      </p:sp>
+    </p:spTree>
+  </p:cSld>
+  <p:clrMapOvr>
+    <a:masterClrMapping/>
+  </p:clrMapOvr>
+</p:notes>
+</file>
+
+<file path=ppt/notesSlides/notesSlide20.xml><?xml version="1.0" encoding="utf-8"?>
+<p:notes xmlns:a="http://schemas.openxmlformats.org/drawingml/2006/main" xmlns:p="http://schemas.openxmlformats.org/presentationml/2006/main" xmlns:r="http://schemas.openxmlformats.org/officeDocument/2006/relationships">
+  <p:cSld>
+    <p:spTree>
+      <p:nvGrpSpPr>
+        <p:cNvPr id="1" name=""/>
+        <p:cNvGrpSpPr/>
+        <p:nvPr/>
+      </p:nvGrpSpPr>
+      <p:grpSpPr>
+        <a:xfrm>
+          <a:off x="0" y="0"/>
+          <a:ext cx="0" cy="0"/>
+          <a:chOff x="0" y="0"/>
+          <a:chExt cx="0" cy="0"/>
+        </a:xfrm>
+      </p:grpSpPr>
+      <p:sp>
+        <p:nvSpPr>
+          <p:cNvPr id="2" name="Slide Image Placeholder 1"/>
+          <p:cNvSpPr>
+            <a:spLocks noGrp="1"/>
+          </p:cNvSpPr>
+          <p:nvPr>
+            <p:ph type="sldImg" idx="2"/>
+          </p:nvPr>
+        </p:nvSpPr>
+        <p:spPr/>
+      </p:sp>
+      <p:sp>
+        <p:nvSpPr>
+          <p:cNvPr id="3" name="Notes Placeholder 2"/>
+          <p:cNvSpPr>
+            <a:spLocks noGrp="1"/>
+          </p:cNvSpPr>
+          <p:nvPr>
+            <p:ph type="body" idx="3" sz="quarter"/>
+          </p:nvPr>
+        </p:nvSpPr>
+        <p:spPr/>
+        <p:txBody>
+          <a:bodyPr/>
+          <a:lstStyle/>
+          <a:p>
+            <a:r>
+              <a:t>(2분) 3개 카드 순서대로. Auto-accept는 "신뢰가 쌓인 뒤" — 첫 주부터 켜지 말라고 조언.</a:t>
+            </a:r>
+          </a:p>
+          <a:p>
+            <a:r>
+              <a:t>하단 주의 문구 읽기: 자동 모드에서도 위험 명령은 다시 물어봄.</a:t>
+            </a:r>
+          </a:p>
+        </p:txBody>
+      </p:sp>
+      <p:sp>
+        <p:nvSpPr>
+          <p:cNvPr id="4" name="Slide Number Placeholder 3"/>
+          <p:cNvSpPr>
+            <a:spLocks noGrp="1"/>
+          </p:cNvSpPr>
+          <p:nvPr>
+            <p:ph type="sldNum" idx="5" sz="quarter"/>
+          </p:nvPr>
+        </p:nvSpPr>
+        <p:spPr/>
+      </p:sp>
+    </p:spTree>
+  </p:cSld>
+  <p:clrMapOvr>
+    <a:masterClrMapping/>
+  </p:clrMapOvr>
+</p:notes>
+</file>
+
+<file path=ppt/notesSlides/notesSlide21.xml><?xml version="1.0" encoding="utf-8"?>
+<p:notes xmlns:a="http://schemas.openxmlformats.org/drawingml/2006/main" xmlns:p="http://schemas.openxmlformats.org/presentationml/2006/main" xmlns:r="http://schemas.openxmlformats.org/officeDocument/2006/relationships">
+  <p:cSld>
+    <p:spTree>
+      <p:nvGrpSpPr>
+        <p:cNvPr id="1" name=""/>
+        <p:cNvGrpSpPr/>
+        <p:nvPr/>
+      </p:nvGrpSpPr>
+      <p:grpSpPr>
+        <a:xfrm>
+          <a:off x="0" y="0"/>
+          <a:ext cx="0" cy="0"/>
+          <a:chOff x="0" y="0"/>
+          <a:chExt cx="0" cy="0"/>
+        </a:xfrm>
+      </p:grpSpPr>
+      <p:sp>
+        <p:nvSpPr>
+          <p:cNvPr id="2" name="Slide Image Placeholder 1"/>
+          <p:cNvSpPr>
+            <a:spLocks noGrp="1"/>
+          </p:cNvSpPr>
+          <p:nvPr>
+            <p:ph type="sldImg" idx="2"/>
+          </p:nvPr>
+        </p:nvSpPr>
+        <p:spPr/>
+      </p:sp>
+      <p:sp>
+        <p:nvSpPr>
+          <p:cNvPr id="3" name="Notes Placeholder 2"/>
+          <p:cNvSpPr>
+            <a:spLocks noGrp="1"/>
+          </p:cNvSpPr>
+          <p:nvPr>
+            <p:ph type="body" idx="3" sz="quarter"/>
+          </p:nvPr>
+        </p:nvSpPr>
+        <p:spPr/>
+        <p:txBody>
+          <a:bodyPr/>
+          <a:lstStyle/>
+          <a:p>
+            <a:r>
+              <a:t>(2분) 다이어그램의 요청 문장을 그대로 읽기 — "이 한 문장이 전부입니다."</a:t>
+            </a:r>
+          </a:p>
+          <a:p>
+            <a:r>
+              <a:t>커밋 메시지 품질이 좋은 이유: diff를 실제로 읽고 쓰기 때문.</a:t>
+            </a:r>
+          </a:p>
+        </p:txBody>
+      </p:sp>
+      <p:sp>
+        <p:nvSpPr>
+          <p:cNvPr id="4" name="Slide Number Placeholder 3"/>
+          <p:cNvSpPr>
+            <a:spLocks noGrp="1"/>
+          </p:cNvSpPr>
+          <p:nvPr>
+            <p:ph type="sldNum" idx="5" sz="quarter"/>
+          </p:nvPr>
+        </p:nvSpPr>
+        <p:spPr/>
+      </p:sp>
+    </p:spTree>
+  </p:cSld>
+  <p:clrMapOvr>
+    <a:masterClrMapping/>
+  </p:clrMapOvr>
+</p:notes>
+</file>
+
+<file path=ppt/notesSlides/notesSlide22.xml><?xml version="1.0" encoding="utf-8"?>
+<p:notes xmlns:a="http://schemas.openxmlformats.org/drawingml/2006/main" xmlns:p="http://schemas.openxmlformats.org/presentationml/2006/main" xmlns:r="http://schemas.openxmlformats.org/officeDocument/2006/relationships">
+  <p:cSld>
+    <p:spTree>
+      <p:nvGrpSpPr>
+        <p:cNvPr id="1" name=""/>
+        <p:cNvGrpSpPr/>
+        <p:nvPr/>
+      </p:nvGrpSpPr>
+      <p:grpSpPr>
+        <a:xfrm>
+          <a:off x="0" y="0"/>
+          <a:ext cx="0" cy="0"/>
+          <a:chOff x="0" y="0"/>
+          <a:chExt cx="0" cy="0"/>
+        </a:xfrm>
+      </p:grpSpPr>
+      <p:sp>
+        <p:nvSpPr>
+          <p:cNvPr id="2" name="Slide Image Placeholder 1"/>
+          <p:cNvSpPr>
+            <a:spLocks noGrp="1"/>
+          </p:cNvSpPr>
+          <p:nvPr>
+            <p:ph type="sldImg" idx="2"/>
+          </p:nvPr>
+        </p:nvSpPr>
+        <p:spPr/>
+      </p:sp>
+      <p:sp>
+        <p:nvSpPr>
+          <p:cNvPr id="3" name="Notes Placeholder 2"/>
+          <p:cNvSpPr>
+            <a:spLocks noGrp="1"/>
+          </p:cNvSpPr>
+          <p:nvPr>
+            <p:ph type="body" idx="3" sz="quarter"/>
+          </p:nvPr>
+        </p:nvSpPr>
+        <p:spPr/>
+        <p:txBody>
+          <a:bodyPr/>
+          <a:lstStyle/>
+          <a:p>
+            <a:r>
+              <a:t>(2분) 의외로 모르는 사람이 많은 기능. Ctrl+V로 터미널에 붙여넣기 가능.</a:t>
+            </a:r>
+          </a:p>
+          <a:p>
+            <a:r>
+              <a:t>디자이너 시안 → 구현 사례가 가장 반응 좋음.</a:t>
+            </a:r>
+          </a:p>
+        </p:txBody>
+      </p:sp>
+      <p:sp>
+        <p:nvSpPr>
+          <p:cNvPr id="4" name="Slide Number Placeholder 3"/>
+          <p:cNvSpPr>
+            <a:spLocks noGrp="1"/>
+          </p:cNvSpPr>
+          <p:nvPr>
+            <p:ph type="sldNum" idx="5" sz="quarter"/>
+          </p:nvPr>
+        </p:nvSpPr>
+        <p:spPr/>
+      </p:sp>
+    </p:spTree>
+  </p:cSld>
+  <p:clrMapOvr>
+    <a:masterClrMapping/>
+  </p:clrMapOvr>
+</p:notes>
+</file>
+
+<file path=ppt/notesSlides/notesSlide23.xml><?xml version="1.0" encoding="utf-8"?>
+<p:notes xmlns:a="http://schemas.openxmlformats.org/drawingml/2006/main" xmlns:p="http://schemas.openxmlformats.org/presentationml/2006/main" xmlns:r="http://schemas.openxmlformats.org/officeDocument/2006/relationships">
+  <p:cSld>
+    <p:spTree>
+      <p:nvGrpSpPr>
+        <p:cNvPr id="1" name=""/>
+        <p:cNvGrpSpPr/>
+        <p:nvPr/>
+      </p:nvGrpSpPr>
+      <p:grpSpPr>
+        <a:xfrm>
+          <a:off x="0" y="0"/>
+          <a:ext cx="0" cy="0"/>
+          <a:chOff x="0" y="0"/>
+          <a:chExt cx="0" cy="0"/>
+        </a:xfrm>
+      </p:grpSpPr>
+      <p:sp>
+        <p:nvSpPr>
+          <p:cNvPr id="2" name="Slide Image Placeholder 1"/>
+          <p:cNvSpPr>
+            <a:spLocks noGrp="1"/>
+          </p:cNvSpPr>
+          <p:nvPr>
+            <p:ph type="sldImg" idx="2"/>
+          </p:nvPr>
+        </p:nvSpPr>
+        <p:spPr/>
+      </p:sp>
+      <p:sp>
+        <p:nvSpPr>
+          <p:cNvPr id="3" name="Notes Placeholder 2"/>
+          <p:cNvSpPr>
+            <a:spLocks noGrp="1"/>
+          </p:cNvSpPr>
+          <p:nvPr>
+            <p:ph type="body" idx="3" sz="quarter"/>
+          </p:nvPr>
+        </p:nvSpPr>
+        <p:spPr/>
+        <p:txBody>
+          <a:bodyPr/>
+          <a:lstStyle/>
+          <a:p>
+            <a:r>
+              <a:t>(2분) "한 대화 = 한 가지 목표" 공식만 기억시키기.</a:t>
+            </a:r>
+          </a:p>
+          <a:p>
+            <a:r>
+              <a:t>길어지면 /compact, 주제 바뀌면 /clear. think hard는 어려운 버그에서 시도해 보라고.</a:t>
+            </a:r>
+          </a:p>
+        </p:txBody>
+      </p:sp>
+      <p:sp>
+        <p:nvSpPr>
+          <p:cNvPr id="4" name="Slide Number Placeholder 3"/>
+          <p:cNvSpPr>
+            <a:spLocks noGrp="1"/>
+          </p:cNvSpPr>
+          <p:nvPr>
+            <p:ph type="sldNum" idx="5" sz="quarter"/>
+          </p:nvPr>
+        </p:nvSpPr>
+        <p:spPr/>
+      </p:sp>
+    </p:spTree>
+  </p:cSld>
+  <p:clrMapOvr>
+    <a:masterClrMapping/>
+  </p:clrMapOvr>
+</p:notes>
+</file>
+
+<file path=ppt/notesSlides/notesSlide24.xml><?xml version="1.0" encoding="utf-8"?>
+<p:notes xmlns:a="http://schemas.openxmlformats.org/drawingml/2006/main" xmlns:p="http://schemas.openxmlformats.org/presentationml/2006/main" xmlns:r="http://schemas.openxmlformats.org/officeDocument/2006/relationships">
+  <p:cSld>
+    <p:spTree>
+      <p:nvGrpSpPr>
+        <p:cNvPr id="1" name=""/>
+        <p:cNvGrpSpPr/>
+        <p:nvPr/>
+      </p:nvGrpSpPr>
+      <p:grpSpPr>
+        <a:xfrm>
+          <a:off x="0" y="0"/>
+          <a:ext cx="0" cy="0"/>
+          <a:chOff x="0" y="0"/>
+          <a:chExt cx="0" cy="0"/>
+        </a:xfrm>
+      </p:grpSpPr>
+      <p:sp>
+        <p:nvSpPr>
+          <p:cNvPr id="2" name="Slide Image Placeholder 1"/>
+          <p:cNvSpPr>
+            <a:spLocks noGrp="1"/>
+          </p:cNvSpPr>
+          <p:nvPr>
+            <p:ph type="sldImg" idx="2"/>
+          </p:nvPr>
+        </p:nvSpPr>
+        <p:spPr/>
+      </p:sp>
+      <p:sp>
+        <p:nvSpPr>
+          <p:cNvPr id="3" name="Notes Placeholder 2"/>
+          <p:cNvSpPr>
+            <a:spLocks noGrp="1"/>
+          </p:cNvSpPr>
+          <p:nvPr>
+            <p:ph type="body" idx="3" sz="quarter"/>
+          </p:nvPr>
+        </p:nvSpPr>
+        <p:spPr/>
+        <p:txBody>
+          <a:bodyPr/>
+          <a:lstStyle/>
+          <a:p>
+            <a:r>
+              <a:t>(8분) 두 번째 라이브 데모 — Plan Mode 전환부터 PR 링크 열기까지.</a:t>
+            </a:r>
+          </a:p>
+          <a:p>
+            <a:r>
+              <a:t>계획을 일부러 한 번 수정시키는 장면을 보여주면 Plan Mode의 가치가 확실히 전달됨.</a:t>
+            </a:r>
+          </a:p>
+        </p:txBody>
+      </p:sp>
+      <p:sp>
+        <p:nvSpPr>
+          <p:cNvPr id="4" name="Slide Number Placeholder 3"/>
+          <p:cNvSpPr>
+            <a:spLocks noGrp="1"/>
+          </p:cNvSpPr>
+          <p:nvPr>
+            <p:ph type="sldNum" idx="5" sz="quarter"/>
+          </p:nvPr>
+        </p:nvSpPr>
+        <p:spPr/>
+      </p:sp>
+    </p:spTree>
+  </p:cSld>
+  <p:clrMapOvr>
+    <a:masterClrMapping/>
+  </p:clrMapOvr>
+</p:notes>
+</file>
+
+<file path=ppt/notesSlides/notesSlide25.xml><?xml version="1.0" encoding="utf-8"?>
+<p:notes xmlns:a="http://schemas.openxmlformats.org/drawingml/2006/main" xmlns:p="http://schemas.openxmlformats.org/presentationml/2006/main" xmlns:r="http://schemas.openxmlformats.org/officeDocument/2006/relationships">
+  <p:cSld>
+    <p:spTree>
+      <p:nvGrpSpPr>
+        <p:cNvPr id="1" name=""/>
+        <p:cNvGrpSpPr/>
+        <p:nvPr/>
+      </p:nvGrpSpPr>
+      <p:grpSpPr>
+        <a:xfrm>
+          <a:off x="0" y="0"/>
+          <a:ext cx="0" cy="0"/>
+          <a:chOff x="0" y="0"/>
+          <a:chExt cx="0" cy="0"/>
+        </a:xfrm>
+      </p:grpSpPr>
+      <p:sp>
+        <p:nvSpPr>
+          <p:cNvPr id="2" name="Slide Image Placeholder 1"/>
+          <p:cNvSpPr>
+            <a:spLocks noGrp="1"/>
+          </p:cNvSpPr>
+          <p:nvPr>
+            <p:ph type="sldImg" idx="2"/>
+          </p:nvPr>
+        </p:nvSpPr>
+        <p:spPr/>
+      </p:sp>
+      <p:sp>
+        <p:nvSpPr>
+          <p:cNvPr id="3" name="Notes Placeholder 2"/>
+          <p:cNvSpPr>
+            <a:spLocks noGrp="1"/>
+          </p:cNvSpPr>
+          <p:nvPr>
+            <p:ph type="body" idx="3" sz="quarter"/>
+          </p:nvPr>
+        </p:nvSpPr>
+        <p:spPr/>
+        <p:txBody>
+          <a:bodyPr/>
+          <a:lstStyle/>
+          <a:p>
+            <a:r>
+              <a:t>(1분) "/init은 오늘 바로"가 핵심 행동 유도.</a:t>
+            </a:r>
+          </a:p>
+          <a:p>
+            <a:r>
+              <a:t>2차 질문 받기.</a:t>
+            </a:r>
+          </a:p>
+        </p:txBody>
+      </p:sp>
+      <p:sp>
+        <p:nvSpPr>
+          <p:cNvPr id="4" name="Slide Number Placeholder 3"/>
+          <p:cNvSpPr>
+            <a:spLocks noGrp="1"/>
+          </p:cNvSpPr>
+          <p:nvPr>
+            <p:ph type="sldNum" idx="5" sz="quarter"/>
+          </p:nvPr>
+        </p:nvSpPr>
+        <p:spPr/>
+      </p:sp>
+    </p:spTree>
+  </p:cSld>
+  <p:clrMapOvr>
+    <a:masterClrMapping/>
+  </p:clrMapOvr>
+</p:notes>
+</file>
+
+<file path=ppt/notesSlides/notesSlide26.xml><?xml version="1.0" encoding="utf-8"?>
+<p:notes xmlns:a="http://schemas.openxmlformats.org/drawingml/2006/main" xmlns:p="http://schemas.openxmlformats.org/presentationml/2006/main" xmlns:r="http://schemas.openxmlformats.org/officeDocument/2006/relationships">
+  <p:cSld>
+    <p:spTree>
+      <p:nvGrpSpPr>
+        <p:cNvPr id="1" name=""/>
+        <p:cNvGrpSpPr/>
+        <p:nvPr/>
+      </p:nvGrpSpPr>
+      <p:grpSpPr>
+        <a:xfrm>
+          <a:off x="0" y="0"/>
+          <a:ext cx="0" cy="0"/>
+          <a:chOff x="0" y="0"/>
+          <a:chExt cx="0" cy="0"/>
+        </a:xfrm>
+      </p:grpSpPr>
+      <p:sp>
+        <p:nvSpPr>
+          <p:cNvPr id="2" name="Slide Image Placeholder 1"/>
+          <p:cNvSpPr>
+            <a:spLocks noGrp="1"/>
+          </p:cNvSpPr>
+          <p:nvPr>
+            <p:ph type="sldImg" idx="2"/>
+          </p:nvPr>
+        </p:nvSpPr>
+        <p:spPr/>
+      </p:sp>
+      <p:sp>
+        <p:nvSpPr>
+          <p:cNvPr id="3" name="Notes Placeholder 2"/>
+          <p:cNvSpPr>
+            <a:spLocks noGrp="1"/>
+          </p:cNvSpPr>
+          <p:nvPr>
+            <p:ph type="body" idx="3" sz="quarter"/>
+          </p:nvPr>
+        </p:nvSpPr>
+        <p:spPr/>
+        <p:txBody>
+          <a:bodyPr/>
+          <a:lstStyle/>
+          <a:p>
+            <a:r>
+              <a:t>(30초) "지금부터는 카탈로그입니다 — 뭐가 있는지만 알아 두세요." 속도 올리기.</a:t>
+            </a:r>
+          </a:p>
+        </p:txBody>
+      </p:sp>
+      <p:sp>
+        <p:nvSpPr>
+          <p:cNvPr id="4" name="Slide Number Placeholder 3"/>
+          <p:cNvSpPr>
+            <a:spLocks noGrp="1"/>
+          </p:cNvSpPr>
+          <p:nvPr>
+            <p:ph type="sldNum" idx="5" sz="quarter"/>
+          </p:nvPr>
+        </p:nvSpPr>
+        <p:spPr/>
+      </p:sp>
+    </p:spTree>
+  </p:cSld>
+  <p:clrMapOvr>
+    <a:masterClrMapping/>
+  </p:clrMapOvr>
+</p:notes>
+</file>
+
+<file path=ppt/notesSlides/notesSlide27.xml><?xml version="1.0" encoding="utf-8"?>
+<p:notes xmlns:a="http://schemas.openxmlformats.org/drawingml/2006/main" xmlns:p="http://schemas.openxmlformats.org/presentationml/2006/main" xmlns:r="http://schemas.openxmlformats.org/officeDocument/2006/relationships">
+  <p:cSld>
+    <p:spTree>
+      <p:nvGrpSpPr>
+        <p:cNvPr id="1" name=""/>
+        <p:cNvGrpSpPr/>
+        <p:nvPr/>
+      </p:nvGrpSpPr>
+      <p:grpSpPr>
+        <a:xfrm>
+          <a:off x="0" y="0"/>
+          <a:ext cx="0" cy="0"/>
+          <a:chOff x="0" y="0"/>
+          <a:chExt cx="0" cy="0"/>
+        </a:xfrm>
+      </p:grpSpPr>
+      <p:sp>
+        <p:nvSpPr>
+          <p:cNvPr id="2" name="Slide Image Placeholder 1"/>
+          <p:cNvSpPr>
+            <a:spLocks noGrp="1"/>
+          </p:cNvSpPr>
+          <p:nvPr>
+            <p:ph type="sldImg" idx="2"/>
+          </p:nvPr>
+        </p:nvSpPr>
+        <p:spPr/>
+      </p:sp>
+      <p:sp>
+        <p:nvSpPr>
+          <p:cNvPr id="3" name="Notes Placeholder 2"/>
+          <p:cNvSpPr>
+            <a:spLocks noGrp="1"/>
+          </p:cNvSpPr>
+          <p:nvPr>
+            <p:ph type="body" idx="3" sz="quarter"/>
+          </p:nvPr>
+        </p:nvSpPr>
+        <p:spPr/>
+        <p:txBody>
+          <a:bodyPr/>
+          <a:lstStyle/>
+          <a:p>
+            <a:r>
+              <a:t>(2분) "같은 요청을 3번 타이핑했다면 커맨드로 만들 때" — 파일 하나면 끝이라는 가벼움 강조.</a:t>
+            </a:r>
+          </a:p>
+        </p:txBody>
+      </p:sp>
+      <p:sp>
+        <p:nvSpPr>
+          <p:cNvPr id="4" name="Slide Number Placeholder 3"/>
+          <p:cNvSpPr>
+            <a:spLocks noGrp="1"/>
+          </p:cNvSpPr>
+          <p:nvPr>
+            <p:ph type="sldNum" idx="5" sz="quarter"/>
+          </p:nvPr>
+        </p:nvSpPr>
+        <p:spPr/>
+      </p:sp>
+    </p:spTree>
+  </p:cSld>
+  <p:clrMapOvr>
+    <a:masterClrMapping/>
+  </p:clrMapOvr>
+</p:notes>
+</file>
+
+<file path=ppt/notesSlides/notesSlide28.xml><?xml version="1.0" encoding="utf-8"?>
+<p:notes xmlns:a="http://schemas.openxmlformats.org/drawingml/2006/main" xmlns:p="http://schemas.openxmlformats.org/presentationml/2006/main" xmlns:r="http://schemas.openxmlformats.org/officeDocument/2006/relationships">
+  <p:cSld>
+    <p:spTree>
+      <p:nvGrpSpPr>
+        <p:cNvPr id="1" name=""/>
+        <p:cNvGrpSpPr/>
+        <p:nvPr/>
+      </p:nvGrpSpPr>
+      <p:grpSpPr>
+        <a:xfrm>
+          <a:off x="0" y="0"/>
+          <a:ext cx="0" cy="0"/>
+          <a:chOff x="0" y="0"/>
+          <a:chExt cx="0" cy="0"/>
+        </a:xfrm>
+      </p:grpSpPr>
+      <p:sp>
+        <p:nvSpPr>
+          <p:cNvPr id="2" name="Slide Image Placeholder 1"/>
+          <p:cNvSpPr>
+            <a:spLocks noGrp="1"/>
+          </p:cNvSpPr>
+          <p:nvPr>
+            <p:ph type="sldImg" idx="2"/>
+          </p:nvPr>
+        </p:nvSpPr>
+        <p:spPr/>
+      </p:sp>
+      <p:sp>
+        <p:nvSpPr>
+          <p:cNvPr id="3" name="Notes Placeholder 2"/>
+          <p:cNvSpPr>
+            <a:spLocks noGrp="1"/>
+          </p:cNvSpPr>
+          <p:nvPr>
+            <p:ph type="body" idx="3" sz="quarter"/>
+          </p:nvPr>
+        </p:nvSpPr>
+        <p:spPr/>
+        <p:txBody>
+          <a:bodyPr/>
+          <a:lstStyle/>
+          <a:p>
+            <a:r>
+              <a:t>(2분) '보조 Claude'라는 비유 하나로 충분. 깊이 들어가지 말 것.</a:t>
+            </a:r>
+          </a:p>
+          <a:p>
+            <a:r>
+              <a:t>관심 있는 분은 튜토리얼 영상 EP6 참조 안내.</a:t>
+            </a:r>
+          </a:p>
+        </p:txBody>
+      </p:sp>
+      <p:sp>
+        <p:nvSpPr>
+          <p:cNvPr id="4" name="Slide Number Placeholder 3"/>
+          <p:cNvSpPr>
+            <a:spLocks noGrp="1"/>
+          </p:cNvSpPr>
+          <p:nvPr>
+            <p:ph type="sldNum" idx="5" sz="quarter"/>
+          </p:nvPr>
+        </p:nvSpPr>
+        <p:spPr/>
+      </p:sp>
+    </p:spTree>
+  </p:cSld>
+  <p:clrMapOvr>
+    <a:masterClrMapping/>
+  </p:clrMapOvr>
+</p:notes>
+</file>
+
+<file path=ppt/notesSlides/notesSlide29.xml><?xml version="1.0" encoding="utf-8"?>
+<p:notes xmlns:a="http://schemas.openxmlformats.org/drawingml/2006/main" xmlns:p="http://schemas.openxmlformats.org/presentationml/2006/main" xmlns:r="http://schemas.openxmlformats.org/officeDocument/2006/relationships">
+  <p:cSld>
+    <p:spTree>
+      <p:nvGrpSpPr>
+        <p:cNvPr id="1" name=""/>
+        <p:cNvGrpSpPr/>
+        <p:nvPr/>
+      </p:nvGrpSpPr>
+      <p:grpSpPr>
+        <a:xfrm>
+          <a:off x="0" y="0"/>
+          <a:ext cx="0" cy="0"/>
+          <a:chOff x="0" y="0"/>
+          <a:chExt cx="0" cy="0"/>
+        </a:xfrm>
+      </p:grpSpPr>
+      <p:sp>
+        <p:nvSpPr>
+          <p:cNvPr id="2" name="Slide Image Placeholder 1"/>
+          <p:cNvSpPr>
+            <a:spLocks noGrp="1"/>
+          </p:cNvSpPr>
+          <p:nvPr>
+            <p:ph type="sldImg" idx="2"/>
+          </p:nvPr>
+        </p:nvSpPr>
+        <p:spPr/>
+      </p:sp>
+      <p:sp>
+        <p:nvSpPr>
+          <p:cNvPr id="3" name="Notes Placeholder 2"/>
+          <p:cNvSpPr>
+            <a:spLocks noGrp="1"/>
+          </p:cNvSpPr>
+          <p:nvPr>
+            <p:ph type="body" idx="3" sz="quarter"/>
+          </p:nvPr>
+        </p:nvSpPr>
+        <p:spPr/>
+        <p:txBody>
+          <a:bodyPr/>
+          <a:lstStyle/>
+          <a:p>
+            <a:r>
+              <a:t>(2분) USB 포트 비유. 청중의 실제 도구(Slack? Jira?)를 물어보고 "그거 연결됩니다"로 연결.</a:t>
+            </a:r>
+          </a:p>
+          <a:p>
+            <a:r>
+              <a:t>보안 유의사항 한 줄: 신뢰할 수 있는 서버만.</a:t>
+            </a:r>
+          </a:p>
+        </p:txBody>
+      </p:sp>
+      <p:sp>
+        <p:nvSpPr>
+          <p:cNvPr id="4" name="Slide Number Placeholder 3"/>
+          <p:cNvSpPr>
+            <a:spLocks noGrp="1"/>
+          </p:cNvSpPr>
+          <p:nvPr>
+            <p:ph type="sldNum" idx="5" sz="quarter"/>
+          </p:nvPr>
+        </p:nvSpPr>
+        <p:spPr/>
+      </p:sp>
+    </p:spTree>
+  </p:cSld>
+  <p:clrMapOvr>
+    <a:masterClrMapping/>
+  </p:clrMapOvr>
+</p:notes>
+</file>
+
+<file path=ppt/notesSlides/notesSlide3.xml><?xml version="1.0" encoding="utf-8"?>
+<p:notes xmlns:a="http://schemas.openxmlformats.org/drawingml/2006/main" xmlns:p="http://schemas.openxmlformats.org/presentationml/2006/main" xmlns:r="http://schemas.openxmlformats.org/officeDocument/2006/relationships">
+  <p:cSld>
+    <p:spTree>
+      <p:nvGrpSpPr>
+        <p:cNvPr id="1" name=""/>
+        <p:cNvGrpSpPr/>
+        <p:nvPr/>
+      </p:nvGrpSpPr>
+      <p:grpSpPr>
+        <a:xfrm>
+          <a:off x="0" y="0"/>
+          <a:ext cx="0" cy="0"/>
+          <a:chOff x="0" y="0"/>
+          <a:chExt cx="0" cy="0"/>
+        </a:xfrm>
+      </p:grpSpPr>
+      <p:sp>
+        <p:nvSpPr>
+          <p:cNvPr id="2" name="Slide Image Placeholder 1"/>
+          <p:cNvSpPr>
+            <a:spLocks noGrp="1"/>
+          </p:cNvSpPr>
+          <p:nvPr>
+            <p:ph type="sldImg" idx="2"/>
+          </p:nvPr>
+        </p:nvSpPr>
+        <p:spPr/>
+      </p:sp>
+      <p:sp>
+        <p:nvSpPr>
+          <p:cNvPr id="3" name="Notes Placeholder 2"/>
+          <p:cNvSpPr>
+            <a:spLocks noGrp="1"/>
+          </p:cNvSpPr>
+          <p:nvPr>
+            <p:ph type="body" idx="3" sz="quarter"/>
+          </p:nvPr>
+        </p:nvSpPr>
+        <p:spPr/>
+        <p:txBody>
+          <a:bodyPr/>
+          <a:lstStyle/>
+          <a:p>
+            <a:r>
+              <a:t>(2분) 핵심 문장 강조: 자연어로 말하면 '직접 일하는' 도구.</a:t>
+            </a:r>
+          </a:p>
+          <a:p>
+            <a:r>
+              <a:t>마지막 불릿(승인 기반)을 힘줘서 — "여러분 허락 없이는 한 글자도 안 바뀝니다." 불안감 해소가 도입부의 최우선 과제.</a:t>
+            </a:r>
+          </a:p>
+        </p:txBody>
+      </p:sp>
+      <p:sp>
+        <p:nvSpPr>
+          <p:cNvPr id="4" name="Slide Number Placeholder 3"/>
+          <p:cNvSpPr>
+            <a:spLocks noGrp="1"/>
+          </p:cNvSpPr>
+          <p:nvPr>
+            <p:ph type="sldNum" idx="5" sz="quarter"/>
+          </p:nvPr>
+        </p:nvSpPr>
+        <p:spPr/>
+      </p:sp>
+    </p:spTree>
+  </p:cSld>
+  <p:clrMapOvr>
+    <a:masterClrMapping/>
+  </p:clrMapOvr>
+</p:notes>
+</file>
+
+<file path=ppt/notesSlides/notesSlide30.xml><?xml version="1.0" encoding="utf-8"?>
+<p:notes xmlns:a="http://schemas.openxmlformats.org/drawingml/2006/main" xmlns:p="http://schemas.openxmlformats.org/presentationml/2006/main" xmlns:r="http://schemas.openxmlformats.org/officeDocument/2006/relationships">
+  <p:cSld>
+    <p:spTree>
+      <p:nvGrpSpPr>
+        <p:cNvPr id="1" name=""/>
+        <p:cNvGrpSpPr/>
+        <p:nvPr/>
+      </p:nvGrpSpPr>
+      <p:grpSpPr>
+        <a:xfrm>
+          <a:off x="0" y="0"/>
+          <a:ext cx="0" cy="0"/>
+          <a:chOff x="0" y="0"/>
+          <a:chExt cx="0" cy="0"/>
+        </a:xfrm>
+      </p:grpSpPr>
+      <p:sp>
+        <p:nvSpPr>
+          <p:cNvPr id="2" name="Slide Image Placeholder 1"/>
+          <p:cNvSpPr>
+            <a:spLocks noGrp="1"/>
+          </p:cNvSpPr>
+          <p:nvPr>
+            <p:ph type="sldImg" idx="2"/>
+          </p:nvPr>
+        </p:nvSpPr>
+        <p:spPr/>
+      </p:sp>
+      <p:sp>
+        <p:nvSpPr>
+          <p:cNvPr id="3" name="Notes Placeholder 2"/>
+          <p:cNvSpPr>
+            <a:spLocks noGrp="1"/>
+          </p:cNvSpPr>
+          <p:nvPr>
+            <p:ph type="body" idx="3" sz="quarter"/>
+          </p:nvPr>
+        </p:nvSpPr>
+        <p:spPr/>
+        <p:txBody>
+          <a:bodyPr/>
+          <a:lstStyle/>
+          <a:p>
+            <a:r>
+              <a:t>(2분) 핵심 문장: "CLAUDE.md는 권고, Hooks는 강제."</a:t>
+            </a:r>
+          </a:p>
+          <a:p>
+            <a:r>
+              <a:t>포매터 자동 실행 예가 가장 직관적.</a:t>
+            </a:r>
+          </a:p>
+        </p:txBody>
+      </p:sp>
+      <p:sp>
+        <p:nvSpPr>
+          <p:cNvPr id="4" name="Slide Number Placeholder 3"/>
+          <p:cNvSpPr>
+            <a:spLocks noGrp="1"/>
+          </p:cNvSpPr>
+          <p:nvPr>
+            <p:ph type="sldNum" idx="5" sz="quarter"/>
+          </p:nvPr>
+        </p:nvSpPr>
+        <p:spPr/>
+      </p:sp>
+    </p:spTree>
+  </p:cSld>
+  <p:clrMapOvr>
+    <a:masterClrMapping/>
+  </p:clrMapOvr>
+</p:notes>
+</file>
+
+<file path=ppt/notesSlides/notesSlide31.xml><?xml version="1.0" encoding="utf-8"?>
+<p:notes xmlns:a="http://schemas.openxmlformats.org/drawingml/2006/main" xmlns:p="http://schemas.openxmlformats.org/presentationml/2006/main" xmlns:r="http://schemas.openxmlformats.org/officeDocument/2006/relationships">
+  <p:cSld>
+    <p:spTree>
+      <p:nvGrpSpPr>
+        <p:cNvPr id="1" name=""/>
+        <p:cNvGrpSpPr/>
+        <p:nvPr/>
+      </p:nvGrpSpPr>
+      <p:grpSpPr>
+        <a:xfrm>
+          <a:off x="0" y="0"/>
+          <a:ext cx="0" cy="0"/>
+          <a:chOff x="0" y="0"/>
+          <a:chExt cx="0" cy="0"/>
+        </a:xfrm>
+      </p:grpSpPr>
+      <p:sp>
+        <p:nvSpPr>
+          <p:cNvPr id="2" name="Slide Image Placeholder 1"/>
+          <p:cNvSpPr>
+            <a:spLocks noGrp="1"/>
+          </p:cNvSpPr>
+          <p:nvPr>
+            <p:ph type="sldImg" idx="2"/>
+          </p:nvPr>
+        </p:nvSpPr>
+        <p:spPr/>
+      </p:sp>
+      <p:sp>
+        <p:nvSpPr>
+          <p:cNvPr id="3" name="Notes Placeholder 2"/>
+          <p:cNvSpPr>
+            <a:spLocks noGrp="1"/>
+          </p:cNvSpPr>
+          <p:nvPr>
+            <p:ph type="body" idx="3" sz="quarter"/>
+          </p:nvPr>
+        </p:nvSpPr>
+        <p:spPr/>
+        <p:txBody>
+          <a:bodyPr/>
+          <a:lstStyle/>
+          <a:p>
+            <a:r>
+              <a:t>(2분) 각자 스타일대로: 터미널이 어색하면 IDE 확장부터, 자리를 비울 땐 웹.</a:t>
+            </a:r>
+          </a:p>
+          <a:p>
+            <a:r>
+              <a:t>GitHub Actions @claude 멘션은 팀 도입 시 가장 파급력 큰 기능.</a:t>
+            </a:r>
+          </a:p>
+        </p:txBody>
+      </p:sp>
+      <p:sp>
+        <p:nvSpPr>
+          <p:cNvPr id="4" name="Slide Number Placeholder 3"/>
+          <p:cNvSpPr>
+            <a:spLocks noGrp="1"/>
+          </p:cNvSpPr>
+          <p:nvPr>
+            <p:ph type="sldNum" idx="5" sz="quarter"/>
+          </p:nvPr>
+        </p:nvSpPr>
+        <p:spPr/>
+      </p:sp>
+    </p:spTree>
+  </p:cSld>
+  <p:clrMapOvr>
+    <a:masterClrMapping/>
+  </p:clrMapOvr>
+</p:notes>
+</file>
+
+<file path=ppt/notesSlides/notesSlide32.xml><?xml version="1.0" encoding="utf-8"?>
+<p:notes xmlns:a="http://schemas.openxmlformats.org/drawingml/2006/main" xmlns:p="http://schemas.openxmlformats.org/presentationml/2006/main" xmlns:r="http://schemas.openxmlformats.org/officeDocument/2006/relationships">
+  <p:cSld>
+    <p:spTree>
+      <p:nvGrpSpPr>
+        <p:cNvPr id="1" name=""/>
+        <p:cNvGrpSpPr/>
+        <p:nvPr/>
+      </p:nvGrpSpPr>
+      <p:grpSpPr>
+        <a:xfrm>
+          <a:off x="0" y="0"/>
+          <a:ext cx="0" cy="0"/>
+          <a:chOff x="0" y="0"/>
+          <a:chExt cx="0" cy="0"/>
+        </a:xfrm>
+      </p:grpSpPr>
+      <p:sp>
+        <p:nvSpPr>
+          <p:cNvPr id="2" name="Slide Image Placeholder 1"/>
+          <p:cNvSpPr>
+            <a:spLocks noGrp="1"/>
+          </p:cNvSpPr>
+          <p:nvPr>
+            <p:ph type="sldImg" idx="2"/>
+          </p:nvPr>
+        </p:nvSpPr>
+        <p:spPr/>
+      </p:sp>
+      <p:sp>
+        <p:nvSpPr>
+          <p:cNvPr id="3" name="Notes Placeholder 2"/>
+          <p:cNvSpPr>
+            <a:spLocks noGrp="1"/>
+          </p:cNvSpPr>
+          <p:nvPr>
+            <p:ph type="body" idx="3" sz="quarter"/>
+          </p:nvPr>
+        </p:nvSpPr>
+        <p:spPr/>
+        <p:txBody>
+          <a:bodyPr/>
+          <a:lstStyle/>
+          <a:p>
+            <a:r>
+              <a:t>(1분) 표를 위에서 아래로 빠르게 — "상황이 오면 이 표만 다시 보세요."</a:t>
+            </a:r>
+          </a:p>
+        </p:txBody>
+      </p:sp>
+      <p:sp>
+        <p:nvSpPr>
+          <p:cNvPr id="4" name="Slide Number Placeholder 3"/>
+          <p:cNvSpPr>
+            <a:spLocks noGrp="1"/>
+          </p:cNvSpPr>
+          <p:nvPr>
+            <p:ph type="sldNum" idx="5" sz="quarter"/>
+          </p:nvPr>
+        </p:nvSpPr>
+        <p:spPr/>
+      </p:sp>
+    </p:spTree>
+  </p:cSld>
+  <p:clrMapOvr>
+    <a:masterClrMapping/>
+  </p:clrMapOvr>
+</p:notes>
+</file>
+
+<file path=ppt/notesSlides/notesSlide33.xml><?xml version="1.0" encoding="utf-8"?>
+<p:notes xmlns:a="http://schemas.openxmlformats.org/drawingml/2006/main" xmlns:p="http://schemas.openxmlformats.org/presentationml/2006/main" xmlns:r="http://schemas.openxmlformats.org/officeDocument/2006/relationships">
+  <p:cSld>
+    <p:spTree>
+      <p:nvGrpSpPr>
+        <p:cNvPr id="1" name=""/>
+        <p:cNvGrpSpPr/>
+        <p:nvPr/>
+      </p:nvGrpSpPr>
+      <p:grpSpPr>
+        <a:xfrm>
+          <a:off x="0" y="0"/>
+          <a:ext cx="0" cy="0"/>
+          <a:chOff x="0" y="0"/>
+          <a:chExt cx="0" cy="0"/>
+        </a:xfrm>
+      </p:grpSpPr>
+      <p:sp>
+        <p:nvSpPr>
+          <p:cNvPr id="2" name="Slide Image Placeholder 1"/>
+          <p:cNvSpPr>
+            <a:spLocks noGrp="1"/>
+          </p:cNvSpPr>
+          <p:nvPr>
+            <p:ph type="sldImg" idx="2"/>
+          </p:nvPr>
+        </p:nvSpPr>
+        <p:spPr/>
+      </p:sp>
+      <p:sp>
+        <p:nvSpPr>
+          <p:cNvPr id="3" name="Notes Placeholder 2"/>
+          <p:cNvSpPr>
+            <a:spLocks noGrp="1"/>
+          </p:cNvSpPr>
+          <p:nvPr>
+            <p:ph type="body" idx="3" sz="quarter"/>
+          </p:nvPr>
+        </p:nvSpPr>
+        <p:spPr/>
+        <p:txBody>
+          <a:bodyPr/>
+          <a:lstStyle/>
+          <a:p>
+            <a:r>
+              <a:t>(2분) ①(작게 시작)과 ④(커밋 자주)만 힘줘서. 나머지는 배포 자료로 읽게.</a:t>
+            </a:r>
+          </a:p>
+        </p:txBody>
+      </p:sp>
+      <p:sp>
+        <p:nvSpPr>
+          <p:cNvPr id="4" name="Slide Number Placeholder 3"/>
+          <p:cNvSpPr>
+            <a:spLocks noGrp="1"/>
+          </p:cNvSpPr>
+          <p:nvPr>
+            <p:ph type="sldNum" idx="5" sz="quarter"/>
+          </p:nvPr>
+        </p:nvSpPr>
+        <p:spPr/>
+      </p:sp>
+    </p:spTree>
+  </p:cSld>
+  <p:clrMapOvr>
+    <a:masterClrMapping/>
+  </p:clrMapOvr>
+</p:notes>
+</file>
+
+<file path=ppt/notesSlides/notesSlide34.xml><?xml version="1.0" encoding="utf-8"?>
+<p:notes xmlns:a="http://schemas.openxmlformats.org/drawingml/2006/main" xmlns:p="http://schemas.openxmlformats.org/presentationml/2006/main" xmlns:r="http://schemas.openxmlformats.org/officeDocument/2006/relationships">
+  <p:cSld>
+    <p:spTree>
+      <p:nvGrpSpPr>
+        <p:cNvPr id="1" name=""/>
+        <p:cNvGrpSpPr/>
+        <p:nvPr/>
+      </p:nvGrpSpPr>
+      <p:grpSpPr>
+        <a:xfrm>
+          <a:off x="0" y="0"/>
+          <a:ext cx="0" cy="0"/>
+          <a:chOff x="0" y="0"/>
+          <a:chExt cx="0" cy="0"/>
+        </a:xfrm>
+      </p:grpSpPr>
+      <p:sp>
+        <p:nvSpPr>
+          <p:cNvPr id="2" name="Slide Image Placeholder 1"/>
+          <p:cNvSpPr>
+            <a:spLocks noGrp="1"/>
+          </p:cNvSpPr>
+          <p:nvPr>
+            <p:ph type="sldImg" idx="2"/>
+          </p:nvPr>
+        </p:nvSpPr>
+        <p:spPr/>
+      </p:sp>
+      <p:sp>
+        <p:nvSpPr>
+          <p:cNvPr id="3" name="Notes Placeholder 2"/>
+          <p:cNvSpPr>
+            <a:spLocks noGrp="1"/>
+          </p:cNvSpPr>
+          <p:nvPr>
+            <p:ph type="body" idx="3" sz="quarter"/>
+          </p:nvPr>
+        </p:nvSpPr>
+        <p:spPr/>
+        <p:txBody>
+          <a:bodyPr/>
+          <a:lstStyle/>
+          <a:p>
+            <a:r>
+              <a:t>(2분) 1번(diff 안 읽고 승인)이 가장 중요 — "AI 시대의 기술 부채는 이해 못 한 채 머지한 코드."</a:t>
+            </a:r>
+          </a:p>
+          <a:p>
+            <a:r>
+              <a:t>4번(비밀키) 는 보안팀 대신 전달하는 마음으로.</a:t>
+            </a:r>
+          </a:p>
+        </p:txBody>
+      </p:sp>
+      <p:sp>
+        <p:nvSpPr>
+          <p:cNvPr id="4" name="Slide Number Placeholder 3"/>
+          <p:cNvSpPr>
+            <a:spLocks noGrp="1"/>
+          </p:cNvSpPr>
+          <p:nvPr>
+            <p:ph type="sldNum" idx="5" sz="quarter"/>
+          </p:nvPr>
+        </p:nvSpPr>
+        <p:spPr/>
+      </p:sp>
+    </p:spTree>
+  </p:cSld>
+  <p:clrMapOvr>
+    <a:masterClrMapping/>
+  </p:clrMapOvr>
+</p:notes>
+</file>
+
+<file path=ppt/notesSlides/notesSlide35.xml><?xml version="1.0" encoding="utf-8"?>
+<p:notes xmlns:a="http://schemas.openxmlformats.org/drawingml/2006/main" xmlns:p="http://schemas.openxmlformats.org/presentationml/2006/main" xmlns:r="http://schemas.openxmlformats.org/officeDocument/2006/relationships">
+  <p:cSld>
+    <p:spTree>
+      <p:nvGrpSpPr>
+        <p:cNvPr id="1" name=""/>
+        <p:cNvGrpSpPr/>
+        <p:nvPr/>
+      </p:nvGrpSpPr>
+      <p:grpSpPr>
+        <a:xfrm>
+          <a:off x="0" y="0"/>
+          <a:ext cx="0" cy="0"/>
+          <a:chOff x="0" y="0"/>
+          <a:chExt cx="0" cy="0"/>
+        </a:xfrm>
+      </p:grpSpPr>
+      <p:sp>
+        <p:nvSpPr>
+          <p:cNvPr id="2" name="Slide Image Placeholder 1"/>
+          <p:cNvSpPr>
+            <a:spLocks noGrp="1"/>
+          </p:cNvSpPr>
+          <p:nvPr>
+            <p:ph type="sldImg" idx="2"/>
+          </p:nvPr>
+        </p:nvSpPr>
+        <p:spPr/>
+      </p:sp>
+      <p:sp>
+        <p:nvSpPr>
+          <p:cNvPr id="3" name="Notes Placeholder 2"/>
+          <p:cNvSpPr>
+            <a:spLocks noGrp="1"/>
+          </p:cNvSpPr>
+          <p:nvPr>
+            <p:ph type="body" idx="3" sz="quarter"/>
+          </p:nvPr>
+        </p:nvSpPr>
+        <p:spPr/>
+        <p:txBody>
+          <a:bodyPr/>
+          <a:lstStyle/>
+          <a:p>
+            <a:r>
+              <a:t>(1분) "이 장은 인쇄해서 모니터에 붙이세요." 배포용 파일 위치 안내.</a:t>
+            </a:r>
+          </a:p>
+        </p:txBody>
+      </p:sp>
+      <p:sp>
+        <p:nvSpPr>
+          <p:cNvPr id="4" name="Slide Number Placeholder 3"/>
+          <p:cNvSpPr>
+            <a:spLocks noGrp="1"/>
+          </p:cNvSpPr>
+          <p:nvPr>
+            <p:ph type="sldNum" idx="5" sz="quarter"/>
+          </p:nvPr>
+        </p:nvSpPr>
+        <p:spPr/>
+      </p:sp>
+    </p:spTree>
+  </p:cSld>
+  <p:clrMapOvr>
+    <a:masterClrMapping/>
+  </p:clrMapOvr>
+</p:notes>
+</file>
+
+<file path=ppt/notesSlides/notesSlide36.xml><?xml version="1.0" encoding="utf-8"?>
+<p:notes xmlns:a="http://schemas.openxmlformats.org/drawingml/2006/main" xmlns:p="http://schemas.openxmlformats.org/presentationml/2006/main" xmlns:r="http://schemas.openxmlformats.org/officeDocument/2006/relationships">
+  <p:cSld>
+    <p:spTree>
+      <p:nvGrpSpPr>
+        <p:cNvPr id="1" name=""/>
+        <p:cNvGrpSpPr/>
+        <p:nvPr/>
+      </p:nvGrpSpPr>
+      <p:grpSpPr>
+        <a:xfrm>
+          <a:off x="0" y="0"/>
+          <a:ext cx="0" cy="0"/>
+          <a:chOff x="0" y="0"/>
+          <a:chExt cx="0" cy="0"/>
+        </a:xfrm>
+      </p:grpSpPr>
+      <p:sp>
+        <p:nvSpPr>
+          <p:cNvPr id="2" name="Slide Image Placeholder 1"/>
+          <p:cNvSpPr>
+            <a:spLocks noGrp="1"/>
+          </p:cNvSpPr>
+          <p:nvPr>
+            <p:ph type="sldImg" idx="2"/>
+          </p:nvPr>
+        </p:nvSpPr>
+        <p:spPr/>
+      </p:sp>
+      <p:sp>
+        <p:nvSpPr>
+          <p:cNvPr id="3" name="Notes Placeholder 2"/>
+          <p:cNvSpPr>
+            <a:spLocks noGrp="1"/>
+          </p:cNvSpPr>
+          <p:nvPr>
+            <p:ph type="body" idx="3" sz="quarter"/>
+          </p:nvPr>
+        </p:nvSpPr>
+        <p:spPr/>
+        <p:txBody>
+          <a:bodyPr/>
+          <a:lstStyle/>
+          <a:p>
+            <a:r>
+              <a:t>(1분) 오늘/이번 주/이번 달 3단계 행동 계획 읽기.</a:t>
+            </a:r>
+          </a:p>
+          <a:p>
+            <a:r>
+              <a:t>튜토리얼 영상 시리즈(EP1~8) 링크 공유 예고.</a:t>
+            </a:r>
+          </a:p>
+        </p:txBody>
+      </p:sp>
+      <p:sp>
+        <p:nvSpPr>
+          <p:cNvPr id="4" name="Slide Number Placeholder 3"/>
+          <p:cNvSpPr>
+            <a:spLocks noGrp="1"/>
+          </p:cNvSpPr>
+          <p:nvPr>
+            <p:ph type="sldNum" idx="5" sz="quarter"/>
+          </p:nvPr>
+        </p:nvSpPr>
+        <p:spPr/>
+      </p:sp>
+    </p:spTree>
+  </p:cSld>
+  <p:clrMapOvr>
+    <a:masterClrMapping/>
+  </p:clrMapOvr>
+</p:notes>
+</file>
+
+<file path=ppt/notesSlides/notesSlide37.xml><?xml version="1.0" encoding="utf-8"?>
+<p:notes xmlns:a="http://schemas.openxmlformats.org/drawingml/2006/main" xmlns:p="http://schemas.openxmlformats.org/presentationml/2006/main" xmlns:r="http://schemas.openxmlformats.org/officeDocument/2006/relationships">
+  <p:cSld>
+    <p:spTree>
+      <p:nvGrpSpPr>
+        <p:cNvPr id="1" name=""/>
+        <p:cNvGrpSpPr/>
+        <p:nvPr/>
+      </p:nvGrpSpPr>
+      <p:grpSpPr>
+        <a:xfrm>
+          <a:off x="0" y="0"/>
+          <a:ext cx="0" cy="0"/>
+          <a:chOff x="0" y="0"/>
+          <a:chExt cx="0" cy="0"/>
+        </a:xfrm>
+      </p:grpSpPr>
+      <p:sp>
+        <p:nvSpPr>
+          <p:cNvPr id="2" name="Slide Image Placeholder 1"/>
+          <p:cNvSpPr>
+            <a:spLocks noGrp="1"/>
+          </p:cNvSpPr>
+          <p:nvPr>
+            <p:ph type="sldImg" idx="2"/>
+          </p:nvPr>
+        </p:nvSpPr>
+        <p:spPr/>
+      </p:sp>
+      <p:sp>
+        <p:nvSpPr>
+          <p:cNvPr id="3" name="Notes Placeholder 2"/>
+          <p:cNvSpPr>
+            <a:spLocks noGrp="1"/>
+          </p:cNvSpPr>
+          <p:nvPr>
+            <p:ph type="body" idx="3" sz="quarter"/>
+          </p:nvPr>
+        </p:nvSpPr>
+        <p:spPr/>
+        <p:txBody>
+          <a:bodyPr/>
+          <a:lstStyle/>
+          <a:p>
+            <a:r>
+              <a:t>마무리 멘트: "가장 좋은 시작은 지금 터미널을 열고 claude 라고 치는 것."</a:t>
+            </a:r>
+          </a:p>
+          <a:p>
+            <a:r>
+              <a:t>Q&amp;A 후 실습 세션이 있다면 안내.</a:t>
+            </a:r>
+          </a:p>
+        </p:txBody>
+      </p:sp>
+      <p:sp>
+        <p:nvSpPr>
+          <p:cNvPr id="4" name="Slide Number Placeholder 3"/>
+          <p:cNvSpPr>
+            <a:spLocks noGrp="1"/>
+          </p:cNvSpPr>
+          <p:nvPr>
+            <p:ph type="sldNum" idx="5" sz="quarter"/>
+          </p:nvPr>
+        </p:nvSpPr>
+        <p:spPr/>
+      </p:sp>
+    </p:spTree>
+  </p:cSld>
+  <p:clrMapOvr>
+    <a:masterClrMapping/>
+  </p:clrMapOvr>
+</p:notes>
+</file>
+
+<file path=ppt/notesSlides/notesSlide4.xml><?xml version="1.0" encoding="utf-8"?>
+<p:notes xmlns:a="http://schemas.openxmlformats.org/drawingml/2006/main" xmlns:p="http://schemas.openxmlformats.org/presentationml/2006/main" xmlns:r="http://schemas.openxmlformats.org/officeDocument/2006/relationships">
+  <p:cSld>
+    <p:spTree>
+      <p:nvGrpSpPr>
+        <p:cNvPr id="1" name=""/>
+        <p:cNvGrpSpPr/>
+        <p:nvPr/>
+      </p:nvGrpSpPr>
+      <p:grpSpPr>
+        <a:xfrm>
+          <a:off x="0" y="0"/>
+          <a:ext cx="0" cy="0"/>
+          <a:chOff x="0" y="0"/>
+          <a:chExt cx="0" cy="0"/>
+        </a:xfrm>
+      </p:grpSpPr>
+      <p:sp>
+        <p:nvSpPr>
+          <p:cNvPr id="2" name="Slide Image Placeholder 1"/>
+          <p:cNvSpPr>
+            <a:spLocks noGrp="1"/>
+          </p:cNvSpPr>
+          <p:nvPr>
+            <p:ph type="sldImg" idx="2"/>
+          </p:nvPr>
+        </p:nvSpPr>
+        <p:spPr/>
+      </p:sp>
+      <p:sp>
+        <p:nvSpPr>
+          <p:cNvPr id="3" name="Notes Placeholder 2"/>
+          <p:cNvSpPr>
+            <a:spLocks noGrp="1"/>
+          </p:cNvSpPr>
+          <p:nvPr>
+            <p:ph type="body" idx="3" sz="quarter"/>
+          </p:nvPr>
+        </p:nvSpPr>
+        <p:spPr/>
+        <p:txBody>
+          <a:bodyPr/>
+          <a:lstStyle/>
+          <a:p>
+            <a:r>
+              <a:t>(2분) 왼쪽(자동완성)은 '타자 도우미', 오른쪽(에이전트)은 '주니어 동료'에 비유.</a:t>
+            </a:r>
+          </a:p>
+          <a:p>
+            <a:r>
+              <a:t>하단 플로우(계획→탐색→수정→검증→커밋)를 손으로 짚으며 "이 전체 루프를 돈다"고 설명.</a:t>
+            </a:r>
+          </a:p>
+        </p:txBody>
+      </p:sp>
+      <p:sp>
+        <p:nvSpPr>
+          <p:cNvPr id="4" name="Slide Number Placeholder 3"/>
+          <p:cNvSpPr>
+            <a:spLocks noGrp="1"/>
+          </p:cNvSpPr>
+          <p:nvPr>
+            <p:ph type="sldNum" idx="5" sz="quarter"/>
+          </p:nvPr>
+        </p:nvSpPr>
+        <p:spPr/>
+      </p:sp>
+    </p:spTree>
+  </p:cSld>
+  <p:clrMapOvr>
+    <a:masterClrMapping/>
+  </p:clrMapOvr>
+</p:notes>
+</file>
+
+<file path=ppt/notesSlides/notesSlide5.xml><?xml version="1.0" encoding="utf-8"?>
+<p:notes xmlns:a="http://schemas.openxmlformats.org/drawingml/2006/main" xmlns:p="http://schemas.openxmlformats.org/presentationml/2006/main" xmlns:r="http://schemas.openxmlformats.org/officeDocument/2006/relationships">
+  <p:cSld>
+    <p:spTree>
+      <p:nvGrpSpPr>
+        <p:cNvPr id="1" name=""/>
+        <p:cNvGrpSpPr/>
+        <p:nvPr/>
+      </p:nvGrpSpPr>
+      <p:grpSpPr>
+        <a:xfrm>
+          <a:off x="0" y="0"/>
+          <a:ext cx="0" cy="0"/>
+          <a:chOff x="0" y="0"/>
+          <a:chExt cx="0" cy="0"/>
+        </a:xfrm>
+      </p:grpSpPr>
+      <p:sp>
+        <p:nvSpPr>
+          <p:cNvPr id="2" name="Slide Image Placeholder 1"/>
+          <p:cNvSpPr>
+            <a:spLocks noGrp="1"/>
+          </p:cNvSpPr>
+          <p:nvPr>
+            <p:ph type="sldImg" idx="2"/>
+          </p:nvPr>
+        </p:nvSpPr>
+        <p:spPr/>
+      </p:sp>
+      <p:sp>
+        <p:nvSpPr>
+          <p:cNvPr id="3" name="Notes Placeholder 2"/>
+          <p:cNvSpPr>
+            <a:spLocks noGrp="1"/>
+          </p:cNvSpPr>
+          <p:nvPr>
+            <p:ph type="body" idx="3" sz="quarter"/>
+          </p:nvPr>
+        </p:nvSpPr>
+        <p:spPr/>
+        <p:txBody>
+          <a:bodyPr/>
+          <a:lstStyle/>
+          <a:p>
+            <a:r>
+              <a:t>(30초) 전환 멘트: "백문이 불여일견. 5분 안에 세팅 끝내겠습니다."</a:t>
+            </a:r>
+          </a:p>
+        </p:txBody>
+      </p:sp>
+      <p:sp>
+        <p:nvSpPr>
+          <p:cNvPr id="4" name="Slide Number Placeholder 3"/>
+          <p:cNvSpPr>
+            <a:spLocks noGrp="1"/>
+          </p:cNvSpPr>
+          <p:nvPr>
+            <p:ph type="sldNum" idx="5" sz="quarter"/>
+          </p:nvPr>
+        </p:nvSpPr>
+        <p:spPr/>
+      </p:sp>
+    </p:spTree>
+  </p:cSld>
+  <p:clrMapOvr>
+    <a:masterClrMapping/>
+  </p:clrMapOvr>
+</p:notes>
+</file>
+
+<file path=ppt/notesSlides/notesSlide6.xml><?xml version="1.0" encoding="utf-8"?>
+<p:notes xmlns:a="http://schemas.openxmlformats.org/drawingml/2006/main" xmlns:p="http://schemas.openxmlformats.org/presentationml/2006/main" xmlns:r="http://schemas.openxmlformats.org/officeDocument/2006/relationships">
+  <p:cSld>
+    <p:spTree>
+      <p:nvGrpSpPr>
+        <p:cNvPr id="1" name=""/>
+        <p:cNvGrpSpPr/>
+        <p:nvPr/>
+      </p:nvGrpSpPr>
+      <p:grpSpPr>
+        <a:xfrm>
+          <a:off x="0" y="0"/>
+          <a:ext cx="0" cy="0"/>
+          <a:chOff x="0" y="0"/>
+          <a:chExt cx="0" cy="0"/>
+        </a:xfrm>
+      </p:grpSpPr>
+      <p:sp>
+        <p:nvSpPr>
+          <p:cNvPr id="2" name="Slide Image Placeholder 1"/>
+          <p:cNvSpPr>
+            <a:spLocks noGrp="1"/>
+          </p:cNvSpPr>
+          <p:nvPr>
+            <p:ph type="sldImg" idx="2"/>
+          </p:nvPr>
+        </p:nvSpPr>
+        <p:spPr/>
+      </p:sp>
+      <p:sp>
+        <p:nvSpPr>
+          <p:cNvPr id="3" name="Notes Placeholder 2"/>
+          <p:cNvSpPr>
+            <a:spLocks noGrp="1"/>
+          </p:cNvSpPr>
+          <p:nvPr>
+            <p:ph type="body" idx="3" sz="quarter"/>
+          </p:nvPr>
+        </p:nvSpPr>
+        <p:spPr/>
+        <p:txBody>
+          <a:bodyPr/>
+          <a:lstStyle/>
+          <a:p>
+            <a:r>
+              <a:t>(2분) npm 한 줄 강조. Node가 없는 청중이 있으면 nodejs.org에서 LTS 설치 안내.</a:t>
+            </a:r>
+          </a:p>
+          <a:p>
+            <a:r>
+              <a:t>"프로젝트 폴더에서 실행"이 포인트 — 그 폴더가 Claude의 작업 범위가 된다고 설명.</a:t>
+            </a:r>
+          </a:p>
+        </p:txBody>
+      </p:sp>
+      <p:sp>
+        <p:nvSpPr>
+          <p:cNvPr id="4" name="Slide Number Placeholder 3"/>
+          <p:cNvSpPr>
+            <a:spLocks noGrp="1"/>
+          </p:cNvSpPr>
+          <p:nvPr>
+            <p:ph type="sldNum" idx="5" sz="quarter"/>
+          </p:nvPr>
+        </p:nvSpPr>
+        <p:spPr/>
+      </p:sp>
+    </p:spTree>
+  </p:cSld>
+  <p:clrMapOvr>
+    <a:masterClrMapping/>
+  </p:clrMapOvr>
+</p:notes>
+</file>
+
+<file path=ppt/notesSlides/notesSlide7.xml><?xml version="1.0" encoding="utf-8"?>
+<p:notes xmlns:a="http://schemas.openxmlformats.org/drawingml/2006/main" xmlns:p="http://schemas.openxmlformats.org/presentationml/2006/main" xmlns:r="http://schemas.openxmlformats.org/officeDocument/2006/relationships">
+  <p:cSld>
+    <p:spTree>
+      <p:nvGrpSpPr>
+        <p:cNvPr id="1" name=""/>
+        <p:cNvGrpSpPr/>
+        <p:nvPr/>
+      </p:nvGrpSpPr>
+      <p:grpSpPr>
+        <a:xfrm>
+          <a:off x="0" y="0"/>
+          <a:ext cx="0" cy="0"/>
+          <a:chOff x="0" y="0"/>
+          <a:chExt cx="0" cy="0"/>
+        </a:xfrm>
+      </p:grpSpPr>
+      <p:sp>
+        <p:nvSpPr>
+          <p:cNvPr id="2" name="Slide Image Placeholder 1"/>
+          <p:cNvSpPr>
+            <a:spLocks noGrp="1"/>
+          </p:cNvSpPr>
+          <p:nvPr>
+            <p:ph type="sldImg" idx="2"/>
+          </p:nvPr>
+        </p:nvSpPr>
+        <p:spPr/>
+      </p:sp>
+      <p:sp>
+        <p:nvSpPr>
+          <p:cNvPr id="3" name="Notes Placeholder 2"/>
+          <p:cNvSpPr>
+            <a:spLocks noGrp="1"/>
+          </p:cNvSpPr>
+          <p:nvPr>
+            <p:ph type="body" idx="3" sz="quarter"/>
+          </p:nvPr>
+        </p:nvSpPr>
+        <p:spPr/>
+        <p:txBody>
+          <a:bodyPr/>
+          <a:lstStyle/>
+          <a:p>
+            <a:r>
+              <a:t>(2분) 요금 질문은 반드시 나옴 — 선제 대응: Pro/Max 구독자는 추가 결제 없음, API는 종량제.</a:t>
+            </a:r>
+          </a:p>
+          <a:p>
+            <a:r>
+              <a:t>사내 규정이 있다면 여기서 언급 (회사 계정 / 개인 계정 정책).</a:t>
+            </a:r>
+          </a:p>
+        </p:txBody>
+      </p:sp>
+      <p:sp>
+        <p:nvSpPr>
+          <p:cNvPr id="4" name="Slide Number Placeholder 3"/>
+          <p:cNvSpPr>
+            <a:spLocks noGrp="1"/>
+          </p:cNvSpPr>
+          <p:nvPr>
+            <p:ph type="sldNum" idx="5" sz="quarter"/>
+          </p:nvPr>
+        </p:nvSpPr>
+        <p:spPr/>
+      </p:sp>
+    </p:spTree>
+  </p:cSld>
+  <p:clrMapOvr>
+    <a:masterClrMapping/>
+  </p:clrMapOvr>
+</p:notes>
+</file>
+
+<file path=ppt/notesSlides/notesSlide8.xml><?xml version="1.0" encoding="utf-8"?>
+<p:notes xmlns:a="http://schemas.openxmlformats.org/drawingml/2006/main" xmlns:p="http://schemas.openxmlformats.org/presentationml/2006/main" xmlns:r="http://schemas.openxmlformats.org/officeDocument/2006/relationships">
+  <p:cSld>
+    <p:spTree>
+      <p:nvGrpSpPr>
+        <p:cNvPr id="1" name=""/>
+        <p:cNvGrpSpPr/>
+        <p:nvPr/>
+      </p:nvGrpSpPr>
+      <p:grpSpPr>
+        <a:xfrm>
+          <a:off x="0" y="0"/>
+          <a:ext cx="0" cy="0"/>
+          <a:chOff x="0" y="0"/>
+          <a:chExt cx="0" cy="0"/>
+        </a:xfrm>
+      </p:grpSpPr>
+      <p:sp>
+        <p:nvSpPr>
+          <p:cNvPr id="2" name="Slide Image Placeholder 1"/>
+          <p:cNvSpPr>
+            <a:spLocks noGrp="1"/>
+          </p:cNvSpPr>
+          <p:nvPr>
+            <p:ph type="sldImg" idx="2"/>
+          </p:nvPr>
+        </p:nvSpPr>
+        <p:spPr/>
+      </p:sp>
+      <p:sp>
+        <p:nvSpPr>
+          <p:cNvPr id="3" name="Notes Placeholder 2"/>
+          <p:cNvSpPr>
+            <a:spLocks noGrp="1"/>
+          </p:cNvSpPr>
+          <p:nvPr>
+            <p:ph type="body" idx="3" sz="quarter"/>
+          </p:nvPr>
+        </p:nvSpPr>
+        <p:spPr/>
+        <p:txBody>
+          <a:bodyPr/>
+          <a:lstStyle/>
+          <a:p>
+            <a:r>
+              <a:t>(2분) "읽기 질문은 코드를 안 바꾼다"를 반복 강조 — 심리적 진입장벽 제거.</a:t>
+            </a:r>
+          </a:p>
+          <a:p>
+            <a:r>
+              <a:t>청중에게 자기 프로젝트에 던질 질문 하나씩 생각해 보게 하기.</a:t>
+            </a:r>
+          </a:p>
+        </p:txBody>
+      </p:sp>
+      <p:sp>
+        <p:nvSpPr>
+          <p:cNvPr id="4" name="Slide Number Placeholder 3"/>
+          <p:cNvSpPr>
+            <a:spLocks noGrp="1"/>
+          </p:cNvSpPr>
+          <p:nvPr>
+            <p:ph type="sldNum" idx="5" sz="quarter"/>
+          </p:nvPr>
+        </p:nvSpPr>
+        <p:spPr/>
+      </p:sp>
+    </p:spTree>
+  </p:cSld>
+  <p:clrMapOvr>
+    <a:masterClrMapping/>
+  </p:clrMapOvr>
+</p:notes>
+</file>
+
+<file path=ppt/notesSlides/notesSlide9.xml><?xml version="1.0" encoding="utf-8"?>
+<p:notes xmlns:a="http://schemas.openxmlformats.org/drawingml/2006/main" xmlns:p="http://schemas.openxmlformats.org/presentationml/2006/main" xmlns:r="http://schemas.openxmlformats.org/officeDocument/2006/relationships">
+  <p:cSld>
+    <p:spTree>
+      <p:nvGrpSpPr>
+        <p:cNvPr id="1" name=""/>
+        <p:cNvGrpSpPr/>
+        <p:nvPr/>
+      </p:nvGrpSpPr>
+      <p:grpSpPr>
+        <a:xfrm>
+          <a:off x="0" y="0"/>
+          <a:ext cx="0" cy="0"/>
+          <a:chOff x="0" y="0"/>
+          <a:chExt cx="0" cy="0"/>
+        </a:xfrm>
+      </p:grpSpPr>
+      <p:sp>
+        <p:nvSpPr>
+          <p:cNvPr id="2" name="Slide Image Placeholder 1"/>
+          <p:cNvSpPr>
+            <a:spLocks noGrp="1"/>
+          </p:cNvSpPr>
+          <p:nvPr>
+            <p:ph type="sldImg" idx="2"/>
+          </p:nvPr>
+        </p:nvSpPr>
+        <p:spPr/>
+      </p:sp>
+      <p:sp>
+        <p:nvSpPr>
+          <p:cNvPr id="3" name="Notes Placeholder 2"/>
+          <p:cNvSpPr>
+            <a:spLocks noGrp="1"/>
+          </p:cNvSpPr>
+          <p:nvPr>
+            <p:ph type="body" idx="3" sz="quarter"/>
+          </p:nvPr>
+        </p:nvSpPr>
+        <p:spPr/>
+        <p:txBody>
+          <a:bodyPr/>
+          <a:lstStyle/>
+          <a:p>
+            <a:r>
+              <a:t>(2분) 스크린샷의 3가지 선택지를 하나씩 읽기.</a:t>
+            </a:r>
+          </a:p>
+          <a:p>
+            <a:r>
+              <a:t>"diff를 읽는 습관이 실력입니다" — 이해 못 한 코드를 쌓지 말라는 메시지. Esc Esc는 뒤에서 다시 다룸.</a:t>
+            </a:r>
+          </a:p>
+        </p:txBody>
+      </p:sp>
+      <p:sp>
+        <p:nvSpPr>
+          <p:cNvPr id="4" name="Slide Number Placeholder 3"/>
+          <p:cNvSpPr>
+            <a:spLocks noGrp="1"/>
+          </p:cNvSpPr>
+          <p:nvPr>
+            <p:ph type="sldNum" idx="5" sz="quarter"/>
+          </p:nvPr>
+        </p:nvSpPr>
+        <p:spPr/>
+      </p:sp>
+    </p:spTree>
+  </p:cSld>
+  <p:clrMapOvr>
+    <a:masterClrMapping/>
+  </p:clrMapOvr>
+</p:notes>
 </file>
 
 <file path=ppt/slideLayouts/slideLayout1.xml><?xml version="1.0" encoding="utf-8"?>
@@ -19652,4 +22737,324 @@
   </a:objectDefaults>
   <a:extraClrSchemeLst/>
 </a:theme>
+</file>
+
+<file path=ppt/theme/theme2.xml><?xml version="1.0" encoding="utf-8"?>
+<a:theme xmlns:a="http://schemas.openxmlformats.org/drawingml/2006/main" name="Office Theme">
+  <a:themeElements>
+    <a:clrScheme name="Office">
+      <a:dk1>
+        <a:sysClr val="windowText" lastClr="000000"/>
+      </a:dk1>
+      <a:lt1>
+        <a:sysClr val="window" lastClr="FFFFFF"/>
+      </a:lt1>
+      <a:dk2>
+        <a:srgbClr val="1F497D"/>
+      </a:dk2>
+      <a:lt2>
+        <a:srgbClr val="EEECE1"/>
+      </a:lt2>
+      <a:accent1>
+        <a:srgbClr val="4F81BD"/>
+      </a:accent1>
+      <a:accent2>
+        <a:srgbClr val="C0504D"/>
+      </a:accent2>
+      <a:accent3>
+        <a:srgbClr val="9BBB59"/>
+      </a:accent3>
+      <a:accent4>
+        <a:srgbClr val="8064A2"/>
+      </a:accent4>
+      <a:accent5>
+        <a:srgbClr val="4BACC6"/>
+      </a:accent5>
+      <a:accent6>
+        <a:srgbClr val="F79646"/>
+      </a:accent6>
+      <a:hlink>
+        <a:srgbClr val="0000FF"/>
+      </a:hlink>
+      <a:folHlink>
+        <a:srgbClr val="800080"/>
+      </a:folHlink>
+    </a:clrScheme>
+    <a:fontScheme name="Office">
+      <a:majorFont>
+        <a:latin typeface="Calibri"/>
+        <a:ea typeface=""/>
+        <a:cs typeface=""/>
+        <a:font script="Jpan" typeface="ＭＳ Ｐゴシック"/>
+        <a:font script="Hang" typeface="맑은 고딕"/>
+        <a:font script="Hans" typeface="宋体"/>
+        <a:font script="Hant" typeface="新細明體"/>
+        <a:font script="Arab" typeface="Times New Roman"/>
+        <a:font script="Hebr" typeface="Times New Roman"/>
+        <a:font script="Thai" typeface="Angsana New"/>
+        <a:font script="Ethi" typeface="Nyala"/>
+        <a:font script="Beng" typeface="Vrinda"/>
+        <a:font script="Gujr" typeface="Shruti"/>
+        <a:font script="Khmr" typeface="MoolBoran"/>
+        <a:font script="Knda" typeface="Tunga"/>
+        <a:font script="Guru" typeface="Raavi"/>
+        <a:font script="Cans" typeface="Euphemia"/>
+        <a:font script="Cher" typeface="Plantagenet Cherokee"/>
+        <a:font script="Yiii" typeface="Microsoft Yi Baiti"/>
+        <a:font script="Tibt" typeface="Microsoft Himalaya"/>
+        <a:font script="Thaa" typeface="MV Boli"/>
+        <a:font script="Deva" typeface="Mangal"/>
+        <a:font script="Telu" typeface="Gautami"/>
+        <a:font script="Taml" typeface="Latha"/>
+        <a:font script="Syrc" typeface="Estrangelo Edessa"/>
+        <a:font script="Orya" typeface="Kalinga"/>
+        <a:font script="Mlym" typeface="Kartika"/>
+        <a:font script="Laoo" typeface="DokChampa"/>
+        <a:font script="Sinh" typeface="Iskoola Pota"/>
+        <a:font script="Mong" typeface="Mongolian Baiti"/>
+        <a:font script="Viet" typeface="Times New Roman"/>
+        <a:font script="Uigh" typeface="Microsoft Uighur"/>
+        <a:font script="Geor" typeface="Sylfaen"/>
+      </a:majorFont>
+      <a:minorFont>
+        <a:latin typeface="Calibri"/>
+        <a:ea typeface=""/>
+        <a:cs typeface=""/>
+        <a:font script="Jpan" typeface="ＭＳ Ｐゴシック"/>
+        <a:font script="Hang" typeface="맑은 고딕"/>
+        <a:font script="Hans" typeface="宋体"/>
+        <a:font script="Hant" typeface="新細明體"/>
+        <a:font script="Arab" typeface="Arial"/>
+        <a:font script="Hebr" typeface="Arial"/>
+        <a:font script="Thai" typeface="Cordia New"/>
+        <a:font script="Ethi" typeface="Nyala"/>
+        <a:font script="Beng" typeface="Vrinda"/>
+        <a:font script="Gujr" typeface="Shruti"/>
+        <a:font script="Khmr" typeface="DaunPenh"/>
+        <a:font script="Knda" typeface="Tunga"/>
+        <a:font script="Guru" typeface="Raavi"/>
+        <a:font script="Cans" typeface="Euphemia"/>
+        <a:font script="Cher" typeface="Plantagenet Cherokee"/>
+        <a:font script="Yiii" typeface="Microsoft Yi Baiti"/>
+        <a:font script="Tibt" typeface="Microsoft Himalaya"/>
+        <a:font script="Thaa" typeface="MV Boli"/>
+        <a:font script="Deva" typeface="Mangal"/>
+        <a:font script="Telu" typeface="Gautami"/>
+        <a:font script="Taml" typeface="Latha"/>
+        <a:font script="Syrc" typeface="Estrangelo Edessa"/>
+        <a:font script="Orya" typeface="Kalinga"/>
+        <a:font script="Mlym" typeface="Kartika"/>
+        <a:font script="Laoo" typeface="DokChampa"/>
+        <a:font script="Sinh" typeface="Iskoola Pota"/>
+        <a:font script="Mong" typeface="Mongolian Baiti"/>
+        <a:font script="Viet" typeface="Arial"/>
+        <a:font script="Uigh" typeface="Microsoft Uighur"/>
+        <a:font script="Geor" typeface="Sylfaen"/>
+      </a:minorFont>
+    </a:fontScheme>
+    <a:fmtScheme name="Office">
+      <a:fillStyleLst>
+        <a:solidFill>
+          <a:schemeClr val="phClr"/>
+        </a:solidFill>
+        <a:gradFill rotWithShape="1">
+          <a:gsLst>
+            <a:gs pos="0">
+              <a:schemeClr val="phClr">
+                <a:tint val="50000"/>
+                <a:satMod val="300000"/>
+              </a:schemeClr>
+            </a:gs>
+            <a:gs pos="35000">
+              <a:schemeClr val="phClr">
+                <a:tint val="37000"/>
+                <a:satMod val="300000"/>
+              </a:schemeClr>
+            </a:gs>
+            <a:gs pos="100000">
+              <a:schemeClr val="phClr">
+                <a:tint val="15000"/>
+                <a:satMod val="350000"/>
+              </a:schemeClr>
+            </a:gs>
+          </a:gsLst>
+          <a:lin ang="16200000" scaled="1"/>
+        </a:gradFill>
+        <a:gradFill rotWithShape="1">
+          <a:gsLst>
+            <a:gs pos="0">
+              <a:schemeClr val="phClr">
+                <a:tint val="100000"/>
+                <a:shade val="100000"/>
+                <a:satMod val="130000"/>
+              </a:schemeClr>
+            </a:gs>
+            <a:gs pos="100000">
+              <a:schemeClr val="phClr">
+                <a:tint val="50000"/>
+                <a:shade val="100000"/>
+                <a:satMod val="350000"/>
+              </a:schemeClr>
+            </a:gs>
+          </a:gsLst>
+          <a:lin ang="16200000" scaled="0"/>
+        </a:gradFill>
+      </a:fillStyleLst>
+      <a:lnStyleLst>
+        <a:ln w="9525" cap="flat" cmpd="sng" algn="ctr">
+          <a:solidFill>
+            <a:schemeClr val="phClr">
+              <a:shade val="95000"/>
+              <a:satMod val="105000"/>
+            </a:schemeClr>
+          </a:solidFill>
+          <a:prstDash val="solid"/>
+        </a:ln>
+        <a:ln w="25400" cap="flat" cmpd="sng" algn="ctr">
+          <a:solidFill>
+            <a:schemeClr val="phClr"/>
+          </a:solidFill>
+          <a:prstDash val="solid"/>
+        </a:ln>
+        <a:ln w="38100" cap="flat" cmpd="sng" algn="ctr">
+          <a:solidFill>
+            <a:schemeClr val="phClr"/>
+          </a:solidFill>
+          <a:prstDash val="solid"/>
+        </a:ln>
+      </a:lnStyleLst>
+      <a:effectStyleLst>
+        <a:effectStyle>
+          <a:effectLst>
+            <a:outerShdw blurRad="40000" dist="20000" dir="5400000" rotWithShape="0">
+              <a:srgbClr val="000000">
+                <a:alpha val="38000"/>
+              </a:srgbClr>
+            </a:outerShdw>
+          </a:effectLst>
+        </a:effectStyle>
+        <a:effectStyle>
+          <a:effectLst>
+            <a:outerShdw blurRad="40000" dist="23000" dir="5400000" rotWithShape="0">
+              <a:srgbClr val="000000">
+                <a:alpha val="35000"/>
+              </a:srgbClr>
+            </a:outerShdw>
+          </a:effectLst>
+        </a:effectStyle>
+        <a:effectStyle>
+          <a:effectLst>
+            <a:outerShdw blurRad="40000" dist="23000" dir="5400000" rotWithShape="0">
+              <a:srgbClr val="000000">
+                <a:alpha val="35000"/>
+              </a:srgbClr>
+            </a:outerShdw>
+          </a:effectLst>
+          <a:scene3d>
+            <a:camera prst="orthographicFront">
+              <a:rot lat="0" lon="0" rev="0"/>
+            </a:camera>
+            <a:lightRig rig="threePt" dir="t">
+              <a:rot lat="0" lon="0" rev="1200000"/>
+            </a:lightRig>
+          </a:scene3d>
+          <a:sp3d>
+            <a:bevelT w="63500" h="25400"/>
+          </a:sp3d>
+        </a:effectStyle>
+      </a:effectStyleLst>
+      <a:bgFillStyleLst>
+        <a:solidFill>
+          <a:schemeClr val="phClr"/>
+        </a:solidFill>
+        <a:gradFill rotWithShape="1">
+          <a:gsLst>
+            <a:gs pos="0">
+              <a:schemeClr val="phClr">
+                <a:tint val="40000"/>
+                <a:satMod val="350000"/>
+              </a:schemeClr>
+            </a:gs>
+            <a:gs pos="40000">
+              <a:schemeClr val="phClr">
+                <a:tint val="45000"/>
+                <a:shade val="99000"/>
+                <a:satMod val="350000"/>
+              </a:schemeClr>
+            </a:gs>
+            <a:gs pos="100000">
+              <a:schemeClr val="phClr">
+                <a:shade val="20000"/>
+                <a:satMod val="255000"/>
+              </a:schemeClr>
+            </a:gs>
+          </a:gsLst>
+          <a:path path="circle">
+            <a:fillToRect l="50000" t="-80000" r="50000" b="180000"/>
+          </a:path>
+        </a:gradFill>
+        <a:gradFill rotWithShape="1">
+          <a:gsLst>
+            <a:gs pos="0">
+              <a:schemeClr val="phClr">
+                <a:tint val="80000"/>
+                <a:satMod val="300000"/>
+              </a:schemeClr>
+            </a:gs>
+            <a:gs pos="100000">
+              <a:schemeClr val="phClr">
+                <a:shade val="30000"/>
+                <a:satMod val="200000"/>
+              </a:schemeClr>
+            </a:gs>
+          </a:gsLst>
+          <a:path path="circle">
+            <a:fillToRect l="50000" t="50000" r="50000" b="50000"/>
+          </a:path>
+        </a:gradFill>
+      </a:bgFillStyleLst>
+    </a:fmtScheme>
+  </a:themeElements>
+  <a:objectDefaults>
+    <a:spDef>
+      <a:spPr/>
+      <a:bodyPr/>
+      <a:lstStyle/>
+      <a:style>
+        <a:lnRef idx="1">
+          <a:schemeClr val="accent1"/>
+        </a:lnRef>
+        <a:fillRef idx="3">
+          <a:schemeClr val="accent1"/>
+        </a:fillRef>
+        <a:effectRef idx="2">
+          <a:schemeClr val="accent1"/>
+        </a:effectRef>
+        <a:fontRef idx="minor">
+          <a:schemeClr val="lt1"/>
+        </a:fontRef>
+      </a:style>
+    </a:spDef>
+    <a:lnDef>
+      <a:spPr/>
+      <a:bodyPr/>
+      <a:lstStyle/>
+      <a:style>
+        <a:lnRef idx="2">
+          <a:schemeClr val="accent1"/>
+        </a:lnRef>
+        <a:fillRef idx="0">
+          <a:schemeClr val="accent1"/>
+        </a:fillRef>
+        <a:effectRef idx="1">
+          <a:schemeClr val="accent1"/>
+        </a:effectRef>
+        <a:fontRef idx="minor">
+          <a:schemeClr val="tx1"/>
+        </a:fontRef>
+      </a:style>
+    </a:lnDef>
+  </a:objectDefaults>
+  <a:extraClrSchemeLst/>
+</a:theme>
 </file>
</xml_diff>